<commit_message>
Entrega con mapa visible
</commit_message>
<xml_diff>
--- a/outputs/Sustentacion_Datos_Ecosistema_2026.pptx
+++ b/outputs/Sustentacion_Datos_Ecosistema_2026.pptx
@@ -5,18 +5,18 @@
     <p:sldMasterId id="2147483648" r:id="rId1"/>
   </p:sldMasterIdLst>
   <p:sldIdLst>
-    <p:sldId id="256" r:id="rId7"/>
-    <p:sldId id="257" r:id="rId8"/>
-    <p:sldId id="258" r:id="rId9"/>
-    <p:sldId id="259" r:id="rId10"/>
-    <p:sldId id="260" r:id="rId11"/>
-    <p:sldId id="261" r:id="rId12"/>
-    <p:sldId id="262" r:id="rId13"/>
-    <p:sldId id="263" r:id="rId14"/>
-    <p:sldId id="264" r:id="rId15"/>
-    <p:sldId id="265" r:id="rId16"/>
+    <p:sldId id="256" r:id="rId2"/>
+    <p:sldId id="257" r:id="rId3"/>
+    <p:sldId id="258" r:id="rId4"/>
+    <p:sldId id="259" r:id="rId5"/>
+    <p:sldId id="260" r:id="rId6"/>
+    <p:sldId id="261" r:id="rId7"/>
+    <p:sldId id="262" r:id="rId8"/>
+    <p:sldId id="263" r:id="rId9"/>
+    <p:sldId id="264" r:id="rId10"/>
+    <p:sldId id="265" r:id="rId11"/>
   </p:sldIdLst>
-  <p:sldSz cx="12191695" cy="6858000" type="screen4x3"/>
+  <p:sldSz cx="12192000" cy="6858000"/>
   <p:notesSz cx="6858000" cy="9144000"/>
   <p:defaultTextStyle>
     <a:defPPr>
@@ -113,6 +113,22 @@
       </a:defRPr>
     </a:lvl9pPr>
   </p:defaultTextStyle>
+  <p:extLst>
+    <p:ext uri="{EFAFB233-063F-42B5-8137-9DF3F51BA10A}">
+      <p15:sldGuideLst xmlns:p15="http://schemas.microsoft.com/office/powerpoint/2012/main">
+        <p15:guide id="1" orient="horz" pos="2160">
+          <p15:clr>
+            <a:srgbClr val="A4A3A4"/>
+          </p15:clr>
+        </p15:guide>
+        <p15:guide id="2" pos="2880">
+          <p15:clr>
+            <a:srgbClr val="A4A3A4"/>
+          </p15:clr>
+        </p15:guide>
+      </p15:sldGuideLst>
+    </p:ext>
+  </p:extLst>
 </p:presentation>
 </file>
 
@@ -154,10 +170,9 @@
           <a:lstStyle/>
           <a:p>
             <a:r>
-              <a:rPr lang="en-US" smtClean="0"/>
+              <a:rPr lang="en-US"/>
               <a:t>Click to edit Master title style</a:t>
             </a:r>
-            <a:endParaRPr lang="en-US"/>
           </a:p>
         </p:txBody>
       </p:sp>
@@ -273,10 +288,9 @@
           </a:lstStyle>
           <a:p>
             <a:r>
-              <a:rPr lang="en-US" smtClean="0"/>
+              <a:rPr lang="en-US"/>
               <a:t>Click to edit Master subtitle style</a:t>
             </a:r>
-            <a:endParaRPr lang="en-US"/>
           </a:p>
         </p:txBody>
       </p:sp>
@@ -297,7 +311,7 @@
           <a:p>
             <a:fld id="{5BCAD085-E8A6-8845-BD4E-CB4CCA059FC4}" type="datetimeFigureOut">
               <a:rPr lang="en-US" smtClean="0"/>
-              <a:t>1/27/13</a:t>
+              <a:t>7/21/2026</a:t>
             </a:fld>
             <a:endParaRPr lang="en-US"/>
           </a:p>
@@ -339,7 +353,7 @@
           <a:p>
             <a:fld id="{C1FF6DA9-008F-8B48-92A6-B652298478BF}" type="slidenum">
               <a:rPr lang="en-US" smtClean="0"/>
-              <a:t>‹#›</a:t>
+              <a:t>‹Nº›</a:t>
             </a:fld>
             <a:endParaRPr lang="en-US"/>
           </a:p>
@@ -391,10 +405,9 @@
           <a:lstStyle/>
           <a:p>
             <a:r>
-              <a:rPr lang="en-US" smtClean="0"/>
+              <a:rPr lang="en-US"/>
               <a:t>Click to edit Master title style</a:t>
             </a:r>
-            <a:endParaRPr lang="en-US"/>
           </a:p>
         </p:txBody>
       </p:sp>
@@ -415,38 +428,37 @@
           <a:p>
             <a:pPr lvl="0"/>
             <a:r>
-              <a:rPr lang="en-US" smtClean="0"/>
+              <a:rPr lang="en-US"/>
               <a:t>Click to edit Master text styles</a:t>
             </a:r>
           </a:p>
           <a:p>
             <a:pPr lvl="1"/>
             <a:r>
-              <a:rPr lang="en-US" smtClean="0"/>
+              <a:rPr lang="en-US"/>
               <a:t>Second level</a:t>
             </a:r>
           </a:p>
           <a:p>
             <a:pPr lvl="2"/>
             <a:r>
-              <a:rPr lang="en-US" smtClean="0"/>
+              <a:rPr lang="en-US"/>
               <a:t>Third level</a:t>
             </a:r>
           </a:p>
           <a:p>
             <a:pPr lvl="3"/>
             <a:r>
-              <a:rPr lang="en-US" smtClean="0"/>
+              <a:rPr lang="en-US"/>
               <a:t>Fourth level</a:t>
             </a:r>
           </a:p>
           <a:p>
             <a:pPr lvl="4"/>
             <a:r>
-              <a:rPr lang="en-US" smtClean="0"/>
+              <a:rPr lang="en-US"/>
               <a:t>Fifth level</a:t>
             </a:r>
-            <a:endParaRPr lang="en-US"/>
           </a:p>
         </p:txBody>
       </p:sp>
@@ -467,7 +479,7 @@
           <a:p>
             <a:fld id="{5BCAD085-E8A6-8845-BD4E-CB4CCA059FC4}" type="datetimeFigureOut">
               <a:rPr lang="en-US" smtClean="0"/>
-              <a:t>1/27/13</a:t>
+              <a:t>7/21/2026</a:t>
             </a:fld>
             <a:endParaRPr lang="en-US"/>
           </a:p>
@@ -509,7 +521,7 @@
           <a:p>
             <a:fld id="{C1FF6DA9-008F-8B48-92A6-B652298478BF}" type="slidenum">
               <a:rPr lang="en-US" smtClean="0"/>
-              <a:t>‹#›</a:t>
+              <a:t>‹Nº›</a:t>
             </a:fld>
             <a:endParaRPr lang="en-US"/>
           </a:p>
@@ -566,10 +578,9 @@
           <a:lstStyle/>
           <a:p>
             <a:r>
-              <a:rPr lang="en-US" smtClean="0"/>
+              <a:rPr lang="en-US"/>
               <a:t>Click to edit Master title style</a:t>
             </a:r>
-            <a:endParaRPr lang="en-US"/>
           </a:p>
         </p:txBody>
       </p:sp>
@@ -595,38 +606,37 @@
           <a:p>
             <a:pPr lvl="0"/>
             <a:r>
-              <a:rPr lang="en-US" smtClean="0"/>
+              <a:rPr lang="en-US"/>
               <a:t>Click to edit Master text styles</a:t>
             </a:r>
           </a:p>
           <a:p>
             <a:pPr lvl="1"/>
             <a:r>
-              <a:rPr lang="en-US" smtClean="0"/>
+              <a:rPr lang="en-US"/>
               <a:t>Second level</a:t>
             </a:r>
           </a:p>
           <a:p>
             <a:pPr lvl="2"/>
             <a:r>
-              <a:rPr lang="en-US" smtClean="0"/>
+              <a:rPr lang="en-US"/>
               <a:t>Third level</a:t>
             </a:r>
           </a:p>
           <a:p>
             <a:pPr lvl="3"/>
             <a:r>
-              <a:rPr lang="en-US" smtClean="0"/>
+              <a:rPr lang="en-US"/>
               <a:t>Fourth level</a:t>
             </a:r>
           </a:p>
           <a:p>
             <a:pPr lvl="4"/>
             <a:r>
-              <a:rPr lang="en-US" smtClean="0"/>
+              <a:rPr lang="en-US"/>
               <a:t>Fifth level</a:t>
             </a:r>
-            <a:endParaRPr lang="en-US"/>
           </a:p>
         </p:txBody>
       </p:sp>
@@ -647,7 +657,7 @@
           <a:p>
             <a:fld id="{5BCAD085-E8A6-8845-BD4E-CB4CCA059FC4}" type="datetimeFigureOut">
               <a:rPr lang="en-US" smtClean="0"/>
-              <a:t>1/27/13</a:t>
+              <a:t>7/21/2026</a:t>
             </a:fld>
             <a:endParaRPr lang="en-US"/>
           </a:p>
@@ -689,7 +699,7 @@
           <a:p>
             <a:fld id="{C1FF6DA9-008F-8B48-92A6-B652298478BF}" type="slidenum">
               <a:rPr lang="en-US" smtClean="0"/>
-              <a:t>‹#›</a:t>
+              <a:t>‹Nº›</a:t>
             </a:fld>
             <a:endParaRPr lang="en-US"/>
           </a:p>
@@ -741,10 +751,9 @@
           <a:lstStyle/>
           <a:p>
             <a:r>
-              <a:rPr lang="en-US" smtClean="0"/>
+              <a:rPr lang="en-US"/>
               <a:t>Click to edit Master title style</a:t>
             </a:r>
-            <a:endParaRPr lang="en-US"/>
           </a:p>
         </p:txBody>
       </p:sp>
@@ -765,38 +774,37 @@
           <a:p>
             <a:pPr lvl="0"/>
             <a:r>
-              <a:rPr lang="en-US" smtClean="0"/>
+              <a:rPr lang="en-US"/>
               <a:t>Click to edit Master text styles</a:t>
             </a:r>
           </a:p>
           <a:p>
             <a:pPr lvl="1"/>
             <a:r>
-              <a:rPr lang="en-US" smtClean="0"/>
+              <a:rPr lang="en-US"/>
               <a:t>Second level</a:t>
             </a:r>
           </a:p>
           <a:p>
             <a:pPr lvl="2"/>
             <a:r>
-              <a:rPr lang="en-US" smtClean="0"/>
+              <a:rPr lang="en-US"/>
               <a:t>Third level</a:t>
             </a:r>
           </a:p>
           <a:p>
             <a:pPr lvl="3"/>
             <a:r>
-              <a:rPr lang="en-US" smtClean="0"/>
+              <a:rPr lang="en-US"/>
               <a:t>Fourth level</a:t>
             </a:r>
           </a:p>
           <a:p>
             <a:pPr lvl="4"/>
             <a:r>
-              <a:rPr lang="en-US" smtClean="0"/>
+              <a:rPr lang="en-US"/>
               <a:t>Fifth level</a:t>
             </a:r>
-            <a:endParaRPr lang="en-US"/>
           </a:p>
         </p:txBody>
       </p:sp>
@@ -817,7 +825,7 @@
           <a:p>
             <a:fld id="{5BCAD085-E8A6-8845-BD4E-CB4CCA059FC4}" type="datetimeFigureOut">
               <a:rPr lang="en-US" smtClean="0"/>
-              <a:t>1/27/13</a:t>
+              <a:t>7/21/2026</a:t>
             </a:fld>
             <a:endParaRPr lang="en-US"/>
           </a:p>
@@ -859,7 +867,7 @@
           <a:p>
             <a:fld id="{C1FF6DA9-008F-8B48-92A6-B652298478BF}" type="slidenum">
               <a:rPr lang="en-US" smtClean="0"/>
-              <a:t>‹#›</a:t>
+              <a:t>‹Nº›</a:t>
             </a:fld>
             <a:endParaRPr lang="en-US"/>
           </a:p>
@@ -920,10 +928,9 @@
           </a:lstStyle>
           <a:p>
             <a:r>
-              <a:rPr lang="en-US" smtClean="0"/>
+              <a:rPr lang="en-US"/>
               <a:t>Click to edit Master title style</a:t>
             </a:r>
-            <a:endParaRPr lang="en-US"/>
           </a:p>
         </p:txBody>
       </p:sp>
@@ -1040,7 +1047,7 @@
           <a:p>
             <a:pPr lvl="0"/>
             <a:r>
-              <a:rPr lang="en-US" smtClean="0"/>
+              <a:rPr lang="en-US"/>
               <a:t>Click to edit Master text styles</a:t>
             </a:r>
           </a:p>
@@ -1063,7 +1070,7 @@
           <a:p>
             <a:fld id="{5BCAD085-E8A6-8845-BD4E-CB4CCA059FC4}" type="datetimeFigureOut">
               <a:rPr lang="en-US" smtClean="0"/>
-              <a:t>1/27/13</a:t>
+              <a:t>7/21/2026</a:t>
             </a:fld>
             <a:endParaRPr lang="en-US"/>
           </a:p>
@@ -1105,7 +1112,7 @@
           <a:p>
             <a:fld id="{C1FF6DA9-008F-8B48-92A6-B652298478BF}" type="slidenum">
               <a:rPr lang="en-US" smtClean="0"/>
-              <a:t>‹#›</a:t>
+              <a:t>‹Nº›</a:t>
             </a:fld>
             <a:endParaRPr lang="en-US"/>
           </a:p>
@@ -1157,10 +1164,9 @@
           <a:lstStyle/>
           <a:p>
             <a:r>
-              <a:rPr lang="en-US" smtClean="0"/>
+              <a:rPr lang="en-US"/>
               <a:t>Click to edit Master title style</a:t>
             </a:r>
-            <a:endParaRPr lang="en-US"/>
           </a:p>
         </p:txBody>
       </p:sp>
@@ -1214,38 +1220,37 @@
           <a:p>
             <a:pPr lvl="0"/>
             <a:r>
-              <a:rPr lang="en-US" smtClean="0"/>
+              <a:rPr lang="en-US"/>
               <a:t>Click to edit Master text styles</a:t>
             </a:r>
           </a:p>
           <a:p>
             <a:pPr lvl="1"/>
             <a:r>
-              <a:rPr lang="en-US" smtClean="0"/>
+              <a:rPr lang="en-US"/>
               <a:t>Second level</a:t>
             </a:r>
           </a:p>
           <a:p>
             <a:pPr lvl="2"/>
             <a:r>
-              <a:rPr lang="en-US" smtClean="0"/>
+              <a:rPr lang="en-US"/>
               <a:t>Third level</a:t>
             </a:r>
           </a:p>
           <a:p>
             <a:pPr lvl="3"/>
             <a:r>
-              <a:rPr lang="en-US" smtClean="0"/>
+              <a:rPr lang="en-US"/>
               <a:t>Fourth level</a:t>
             </a:r>
           </a:p>
           <a:p>
             <a:pPr lvl="4"/>
             <a:r>
-              <a:rPr lang="en-US" smtClean="0"/>
+              <a:rPr lang="en-US"/>
               <a:t>Fifth level</a:t>
             </a:r>
-            <a:endParaRPr lang="en-US"/>
           </a:p>
         </p:txBody>
       </p:sp>
@@ -1299,38 +1304,37 @@
           <a:p>
             <a:pPr lvl="0"/>
             <a:r>
-              <a:rPr lang="en-US" smtClean="0"/>
+              <a:rPr lang="en-US"/>
               <a:t>Click to edit Master text styles</a:t>
             </a:r>
           </a:p>
           <a:p>
             <a:pPr lvl="1"/>
             <a:r>
-              <a:rPr lang="en-US" smtClean="0"/>
+              <a:rPr lang="en-US"/>
               <a:t>Second level</a:t>
             </a:r>
           </a:p>
           <a:p>
             <a:pPr lvl="2"/>
             <a:r>
-              <a:rPr lang="en-US" smtClean="0"/>
+              <a:rPr lang="en-US"/>
               <a:t>Third level</a:t>
             </a:r>
           </a:p>
           <a:p>
             <a:pPr lvl="3"/>
             <a:r>
-              <a:rPr lang="en-US" smtClean="0"/>
+              <a:rPr lang="en-US"/>
               <a:t>Fourth level</a:t>
             </a:r>
           </a:p>
           <a:p>
             <a:pPr lvl="4"/>
             <a:r>
-              <a:rPr lang="en-US" smtClean="0"/>
+              <a:rPr lang="en-US"/>
               <a:t>Fifth level</a:t>
             </a:r>
-            <a:endParaRPr lang="en-US"/>
           </a:p>
         </p:txBody>
       </p:sp>
@@ -1351,7 +1355,7 @@
           <a:p>
             <a:fld id="{5BCAD085-E8A6-8845-BD4E-CB4CCA059FC4}" type="datetimeFigureOut">
               <a:rPr lang="en-US" smtClean="0"/>
-              <a:t>1/27/13</a:t>
+              <a:t>7/21/2026</a:t>
             </a:fld>
             <a:endParaRPr lang="en-US"/>
           </a:p>
@@ -1393,7 +1397,7 @@
           <a:p>
             <a:fld id="{C1FF6DA9-008F-8B48-92A6-B652298478BF}" type="slidenum">
               <a:rPr lang="en-US" smtClean="0"/>
-              <a:t>‹#›</a:t>
+              <a:t>‹Nº›</a:t>
             </a:fld>
             <a:endParaRPr lang="en-US"/>
           </a:p>
@@ -1449,10 +1453,9 @@
           </a:lstStyle>
           <a:p>
             <a:r>
-              <a:rPr lang="en-US" smtClean="0"/>
+              <a:rPr lang="en-US"/>
               <a:t>Click to edit Master title style</a:t>
             </a:r>
-            <a:endParaRPr lang="en-US"/>
           </a:p>
         </p:txBody>
       </p:sp>
@@ -1515,7 +1518,7 @@
           <a:p>
             <a:pPr lvl="0"/>
             <a:r>
-              <a:rPr lang="en-US" smtClean="0"/>
+              <a:rPr lang="en-US"/>
               <a:t>Click to edit Master text styles</a:t>
             </a:r>
           </a:p>
@@ -1571,38 +1574,37 @@
           <a:p>
             <a:pPr lvl="0"/>
             <a:r>
-              <a:rPr lang="en-US" smtClean="0"/>
+              <a:rPr lang="en-US"/>
               <a:t>Click to edit Master text styles</a:t>
             </a:r>
           </a:p>
           <a:p>
             <a:pPr lvl="1"/>
             <a:r>
-              <a:rPr lang="en-US" smtClean="0"/>
+              <a:rPr lang="en-US"/>
               <a:t>Second level</a:t>
             </a:r>
           </a:p>
           <a:p>
             <a:pPr lvl="2"/>
             <a:r>
-              <a:rPr lang="en-US" smtClean="0"/>
+              <a:rPr lang="en-US"/>
               <a:t>Third level</a:t>
             </a:r>
           </a:p>
           <a:p>
             <a:pPr lvl="3"/>
             <a:r>
-              <a:rPr lang="en-US" smtClean="0"/>
+              <a:rPr lang="en-US"/>
               <a:t>Fourth level</a:t>
             </a:r>
           </a:p>
           <a:p>
             <a:pPr lvl="4"/>
             <a:r>
-              <a:rPr lang="en-US" smtClean="0"/>
+              <a:rPr lang="en-US"/>
               <a:t>Fifth level</a:t>
             </a:r>
-            <a:endParaRPr lang="en-US"/>
           </a:p>
         </p:txBody>
       </p:sp>
@@ -1665,7 +1667,7 @@
           <a:p>
             <a:pPr lvl="0"/>
             <a:r>
-              <a:rPr lang="en-US" smtClean="0"/>
+              <a:rPr lang="en-US"/>
               <a:t>Click to edit Master text styles</a:t>
             </a:r>
           </a:p>
@@ -1721,38 +1723,37 @@
           <a:p>
             <a:pPr lvl="0"/>
             <a:r>
-              <a:rPr lang="en-US" smtClean="0"/>
+              <a:rPr lang="en-US"/>
               <a:t>Click to edit Master text styles</a:t>
             </a:r>
           </a:p>
           <a:p>
             <a:pPr lvl="1"/>
             <a:r>
-              <a:rPr lang="en-US" smtClean="0"/>
+              <a:rPr lang="en-US"/>
               <a:t>Second level</a:t>
             </a:r>
           </a:p>
           <a:p>
             <a:pPr lvl="2"/>
             <a:r>
-              <a:rPr lang="en-US" smtClean="0"/>
+              <a:rPr lang="en-US"/>
               <a:t>Third level</a:t>
             </a:r>
           </a:p>
           <a:p>
             <a:pPr lvl="3"/>
             <a:r>
-              <a:rPr lang="en-US" smtClean="0"/>
+              <a:rPr lang="en-US"/>
               <a:t>Fourth level</a:t>
             </a:r>
           </a:p>
           <a:p>
             <a:pPr lvl="4"/>
             <a:r>
-              <a:rPr lang="en-US" smtClean="0"/>
+              <a:rPr lang="en-US"/>
               <a:t>Fifth level</a:t>
             </a:r>
-            <a:endParaRPr lang="en-US"/>
           </a:p>
         </p:txBody>
       </p:sp>
@@ -1773,7 +1774,7 @@
           <a:p>
             <a:fld id="{5BCAD085-E8A6-8845-BD4E-CB4CCA059FC4}" type="datetimeFigureOut">
               <a:rPr lang="en-US" smtClean="0"/>
-              <a:t>1/27/13</a:t>
+              <a:t>7/21/2026</a:t>
             </a:fld>
             <a:endParaRPr lang="en-US"/>
           </a:p>
@@ -1815,7 +1816,7 @@
           <a:p>
             <a:fld id="{C1FF6DA9-008F-8B48-92A6-B652298478BF}" type="slidenum">
               <a:rPr lang="en-US" smtClean="0"/>
-              <a:t>‹#›</a:t>
+              <a:t>‹Nº›</a:t>
             </a:fld>
             <a:endParaRPr lang="en-US"/>
           </a:p>
@@ -1867,10 +1868,9 @@
           <a:lstStyle/>
           <a:p>
             <a:r>
-              <a:rPr lang="en-US" smtClean="0"/>
+              <a:rPr lang="en-US"/>
               <a:t>Click to edit Master title style</a:t>
             </a:r>
-            <a:endParaRPr lang="en-US"/>
           </a:p>
         </p:txBody>
       </p:sp>
@@ -1891,7 +1891,7 @@
           <a:p>
             <a:fld id="{5BCAD085-E8A6-8845-BD4E-CB4CCA059FC4}" type="datetimeFigureOut">
               <a:rPr lang="en-US" smtClean="0"/>
-              <a:t>1/27/13</a:t>
+              <a:t>7/21/2026</a:t>
             </a:fld>
             <a:endParaRPr lang="en-US"/>
           </a:p>
@@ -1933,7 +1933,7 @@
           <a:p>
             <a:fld id="{C1FF6DA9-008F-8B48-92A6-B652298478BF}" type="slidenum">
               <a:rPr lang="en-US" smtClean="0"/>
-              <a:t>‹#›</a:t>
+              <a:t>‹Nº›</a:t>
             </a:fld>
             <a:endParaRPr lang="en-US"/>
           </a:p>
@@ -1986,7 +1986,7 @@
           <a:p>
             <a:fld id="{5BCAD085-E8A6-8845-BD4E-CB4CCA059FC4}" type="datetimeFigureOut">
               <a:rPr lang="en-US" smtClean="0"/>
-              <a:t>1/27/13</a:t>
+              <a:t>7/21/2026</a:t>
             </a:fld>
             <a:endParaRPr lang="en-US"/>
           </a:p>
@@ -2028,7 +2028,7 @@
           <a:p>
             <a:fld id="{C1FF6DA9-008F-8B48-92A6-B652298478BF}" type="slidenum">
               <a:rPr lang="en-US" smtClean="0"/>
-              <a:t>‹#›</a:t>
+              <a:t>‹Nº›</a:t>
             </a:fld>
             <a:endParaRPr lang="en-US"/>
           </a:p>
@@ -2089,10 +2089,9 @@
           </a:lstStyle>
           <a:p>
             <a:r>
-              <a:rPr lang="en-US" smtClean="0"/>
+              <a:rPr lang="en-US"/>
               <a:t>Click to edit Master title style</a:t>
             </a:r>
-            <a:endParaRPr lang="en-US"/>
           </a:p>
         </p:txBody>
       </p:sp>
@@ -2146,38 +2145,37 @@
           <a:p>
             <a:pPr lvl="0"/>
             <a:r>
-              <a:rPr lang="en-US" smtClean="0"/>
+              <a:rPr lang="en-US"/>
               <a:t>Click to edit Master text styles</a:t>
             </a:r>
           </a:p>
           <a:p>
             <a:pPr lvl="1"/>
             <a:r>
-              <a:rPr lang="en-US" smtClean="0"/>
+              <a:rPr lang="en-US"/>
               <a:t>Second level</a:t>
             </a:r>
           </a:p>
           <a:p>
             <a:pPr lvl="2"/>
             <a:r>
-              <a:rPr lang="en-US" smtClean="0"/>
+              <a:rPr lang="en-US"/>
               <a:t>Third level</a:t>
             </a:r>
           </a:p>
           <a:p>
             <a:pPr lvl="3"/>
             <a:r>
-              <a:rPr lang="en-US" smtClean="0"/>
+              <a:rPr lang="en-US"/>
               <a:t>Fourth level</a:t>
             </a:r>
           </a:p>
           <a:p>
             <a:pPr lvl="4"/>
             <a:r>
-              <a:rPr lang="en-US" smtClean="0"/>
+              <a:rPr lang="en-US"/>
               <a:t>Fifth level</a:t>
             </a:r>
-            <a:endParaRPr lang="en-US"/>
           </a:p>
         </p:txBody>
       </p:sp>
@@ -2240,7 +2238,7 @@
           <a:p>
             <a:pPr lvl="0"/>
             <a:r>
-              <a:rPr lang="en-US" smtClean="0"/>
+              <a:rPr lang="en-US"/>
               <a:t>Click to edit Master text styles</a:t>
             </a:r>
           </a:p>
@@ -2263,7 +2261,7 @@
           <a:p>
             <a:fld id="{5BCAD085-E8A6-8845-BD4E-CB4CCA059FC4}" type="datetimeFigureOut">
               <a:rPr lang="en-US" smtClean="0"/>
-              <a:t>1/27/13</a:t>
+              <a:t>7/21/2026</a:t>
             </a:fld>
             <a:endParaRPr lang="en-US"/>
           </a:p>
@@ -2305,7 +2303,7 @@
           <a:p>
             <a:fld id="{C1FF6DA9-008F-8B48-92A6-B652298478BF}" type="slidenum">
               <a:rPr lang="en-US" smtClean="0"/>
-              <a:t>‹#›</a:t>
+              <a:t>‹Nº›</a:t>
             </a:fld>
             <a:endParaRPr lang="en-US"/>
           </a:p>
@@ -2366,10 +2364,9 @@
           </a:lstStyle>
           <a:p>
             <a:r>
-              <a:rPr lang="en-US" smtClean="0"/>
+              <a:rPr lang="en-US"/>
               <a:t>Click to edit Master title style</a:t>
             </a:r>
-            <a:endParaRPr lang="en-US"/>
           </a:p>
         </p:txBody>
       </p:sp>
@@ -2493,7 +2490,7 @@
           <a:p>
             <a:pPr lvl="0"/>
             <a:r>
-              <a:rPr lang="en-US" smtClean="0"/>
+              <a:rPr lang="en-US"/>
               <a:t>Click to edit Master text styles</a:t>
             </a:r>
           </a:p>
@@ -2516,7 +2513,7 @@
           <a:p>
             <a:fld id="{5BCAD085-E8A6-8845-BD4E-CB4CCA059FC4}" type="datetimeFigureOut">
               <a:rPr lang="en-US" smtClean="0"/>
-              <a:t>1/27/13</a:t>
+              <a:t>7/21/2026</a:t>
             </a:fld>
             <a:endParaRPr lang="en-US"/>
           </a:p>
@@ -2558,7 +2555,7 @@
           <a:p>
             <a:fld id="{C1FF6DA9-008F-8B48-92A6-B652298478BF}" type="slidenum">
               <a:rPr lang="en-US" smtClean="0"/>
-              <a:t>‹#›</a:t>
+              <a:t>‹Nº›</a:t>
             </a:fld>
             <a:endParaRPr lang="en-US"/>
           </a:p>
@@ -2625,10 +2622,9 @@
           <a:lstStyle/>
           <a:p>
             <a:r>
-              <a:rPr lang="en-US" smtClean="0"/>
+              <a:rPr lang="en-US"/>
               <a:t>Click to edit Master title style</a:t>
             </a:r>
-            <a:endParaRPr lang="en-US"/>
           </a:p>
         </p:txBody>
       </p:sp>
@@ -2659,38 +2655,37 @@
           <a:p>
             <a:pPr lvl="0"/>
             <a:r>
-              <a:rPr lang="en-US" smtClean="0"/>
+              <a:rPr lang="en-US"/>
               <a:t>Click to edit Master text styles</a:t>
             </a:r>
           </a:p>
           <a:p>
             <a:pPr lvl="1"/>
             <a:r>
-              <a:rPr lang="en-US" smtClean="0"/>
+              <a:rPr lang="en-US"/>
               <a:t>Second level</a:t>
             </a:r>
           </a:p>
           <a:p>
             <a:pPr lvl="2"/>
             <a:r>
-              <a:rPr lang="en-US" smtClean="0"/>
+              <a:rPr lang="en-US"/>
               <a:t>Third level</a:t>
             </a:r>
           </a:p>
           <a:p>
             <a:pPr lvl="3"/>
             <a:r>
-              <a:rPr lang="en-US" smtClean="0"/>
+              <a:rPr lang="en-US"/>
               <a:t>Fourth level</a:t>
             </a:r>
           </a:p>
           <a:p>
             <a:pPr lvl="4"/>
             <a:r>
-              <a:rPr lang="en-US" smtClean="0"/>
+              <a:rPr lang="en-US"/>
               <a:t>Fifth level</a:t>
             </a:r>
-            <a:endParaRPr lang="en-US"/>
           </a:p>
         </p:txBody>
       </p:sp>
@@ -2729,7 +2724,7 @@
           <a:p>
             <a:fld id="{5BCAD085-E8A6-8845-BD4E-CB4CCA059FC4}" type="datetimeFigureOut">
               <a:rPr lang="en-US" smtClean="0"/>
-              <a:t>1/27/13</a:t>
+              <a:t>7/21/2026</a:t>
             </a:fld>
             <a:endParaRPr lang="en-US"/>
           </a:p>
@@ -2807,7 +2802,7 @@
           <a:p>
             <a:fld id="{C1FF6DA9-008F-8B48-92A6-B652298478BF}" type="slidenum">
               <a:rPr lang="en-US" smtClean="0"/>
-              <a:t>‹#›</a:t>
+              <a:t>‹Nº›</a:t>
             </a:fld>
             <a:endParaRPr lang="en-US"/>
           </a:p>
@@ -3088,7 +3083,7 @@
 </file>
 
 <file path=ppt/slides/slide1.xml><?xml version="1.0" encoding="utf-8"?>
-<p:sld xmlns:a="http://schemas.openxmlformats.org/drawingml/2006/main" xmlns:p="http://schemas.openxmlformats.org/presentationml/2006/main" xmlns:r="http://schemas.openxmlformats.org/officeDocument/2006/relationships">
+<p:sld xmlns:a="http://schemas.openxmlformats.org/drawingml/2006/main" xmlns:r="http://schemas.openxmlformats.org/officeDocument/2006/relationships" xmlns:p="http://schemas.openxmlformats.org/presentationml/2006/main">
   <p:cSld>
     <p:spTree>
       <p:nvGrpSpPr>
@@ -3096,7 +3091,14 @@
         <p:cNvGrpSpPr/>
         <p:nvPr/>
       </p:nvGrpSpPr>
-      <p:grpSpPr/>
+      <p:grpSpPr>
+        <a:xfrm>
+          <a:off x="0" y="0"/>
+          <a:ext cx="0" cy="0"/>
+          <a:chOff x="0" y="0"/>
+          <a:chExt cx="0" cy="0"/>
+        </a:xfrm>
+      </p:grpSpPr>
       <p:sp>
         <p:nvSpPr>
           <p:cNvPr id="2" name="Rectangle 1"/>
@@ -3138,6 +3140,7 @@
           <a:lstStyle/>
           <a:p>
             <a:pPr algn="ctr"/>
+            <a:endParaRPr/>
           </a:p>
         </p:txBody>
       </p:sp>
@@ -3182,6 +3185,7 @@
           <a:lstStyle/>
           <a:p>
             <a:pPr algn="ctr"/>
+            <a:endParaRPr/>
           </a:p>
         </p:txBody>
       </p:sp>
@@ -3226,6 +3230,7 @@
           <a:lstStyle/>
           <a:p>
             <a:pPr algn="ctr"/>
+            <a:endParaRPr/>
           </a:p>
         </p:txBody>
       </p:sp>
@@ -3246,7 +3251,7 @@
           <a:noFill/>
         </p:spPr>
         <p:txBody>
-          <a:bodyPr wrap="square" anchor="t" lIns="0" rIns="0" tIns="0" bIns="0">
+          <a:bodyPr wrap="square" lIns="0" tIns="0" rIns="0" bIns="0" anchor="t">
             <a:spAutoFit/>
           </a:bodyPr>
           <a:lstStyle/>
@@ -3281,7 +3286,7 @@
           <a:noFill/>
         </p:spPr>
         <p:txBody>
-          <a:bodyPr wrap="square" anchor="t" lIns="0" rIns="0" tIns="0" bIns="0">
+          <a:bodyPr wrap="square" lIns="0" tIns="0" rIns="0" bIns="0" anchor="t">
             <a:spAutoFit/>
           </a:bodyPr>
           <a:lstStyle/>
@@ -3361,6 +3366,7 @@
           <a:lstStyle/>
           <a:p>
             <a:pPr algn="ctr"/>
+            <a:endParaRPr/>
           </a:p>
         </p:txBody>
       </p:sp>
@@ -3405,6 +3411,7 @@
           <a:lstStyle/>
           <a:p>
             <a:pPr algn="ctr"/>
+            <a:endParaRPr/>
           </a:p>
         </p:txBody>
       </p:sp>
@@ -3417,7 +3424,7 @@
         <p:spPr>
           <a:xfrm>
             <a:off x="1143000" y="4160520"/>
-            <a:ext cx="9966960" cy="1463040"/>
+            <a:ext cx="9966960" cy="1333698"/>
           </a:xfrm>
           <a:prstGeom prst="rect">
             <a:avLst/>
@@ -3425,7 +3432,7 @@
           <a:noFill/>
         </p:spPr>
         <p:txBody>
-          <a:bodyPr wrap="square" anchor="t" lIns="0" rIns="0" tIns="0" bIns="0">
+          <a:bodyPr wrap="square" lIns="0" tIns="0" rIns="0" bIns="0" anchor="t">
             <a:spAutoFit/>
           </a:bodyPr>
           <a:lstStyle/>
@@ -3436,7 +3443,7 @@
               </a:spcAft>
             </a:pPr>
             <a:r>
-              <a:rPr sz="1400" b="1" i="0">
+              <a:rPr sz="1400" b="1" i="0" dirty="0">
                 <a:solidFill>
                   <a:srgbClr val="E09F2C"/>
                 </a:solidFill>
@@ -3445,7 +3452,7 @@
               <a:t>Nivel:  </a:t>
             </a:r>
             <a:r>
-              <a:rPr sz="1400" b="0" i="0">
+              <a:rPr sz="1400" b="0" i="0" dirty="0" err="1">
                 <a:solidFill>
                   <a:srgbClr val="FFFFFF"/>
                 </a:solidFill>
@@ -3453,6 +3460,12 @@
               </a:rPr>
               <a:t>Intermedio</a:t>
             </a:r>
+            <a:endParaRPr sz="1400" b="0" i="0" dirty="0">
+              <a:solidFill>
+                <a:srgbClr val="FFFFFF"/>
+              </a:solidFill>
+              <a:latin typeface="Calibri"/>
+            </a:endParaRPr>
           </a:p>
           <a:p>
             <a:pPr algn="l">
@@ -3461,23 +3474,122 @@
               </a:spcAft>
             </a:pPr>
             <a:r>
-              <a:rPr sz="1400" b="1" i="0">
+              <a:rPr sz="1400" b="1" i="0" dirty="0">
                 <a:solidFill>
                   <a:srgbClr val="E09F2C"/>
                 </a:solidFill>
                 <a:latin typeface="Calibri"/>
               </a:rPr>
-              <a:t>ID del equipo:  </a:t>
-            </a:r>
-            <a:r>
-              <a:rPr sz="1400" b="0" i="0">
+              <a:t>ID del </a:t>
+            </a:r>
+            <a:r>
+              <a:rPr sz="1400" b="1" i="0" dirty="0" err="1">
+                <a:solidFill>
+                  <a:srgbClr val="E09F2C"/>
+                </a:solidFill>
+                <a:latin typeface="Calibri"/>
+              </a:rPr>
+              <a:t>equipo</a:t>
+            </a:r>
+            <a:r>
+              <a:rPr sz="1400" b="1" i="0" dirty="0">
+                <a:solidFill>
+                  <a:srgbClr val="E09F2C"/>
+                </a:solidFill>
+                <a:latin typeface="Calibri"/>
+              </a:rPr>
+              <a:t>:  </a:t>
+            </a:r>
+            <a:r>
+              <a:rPr lang="es-CO" sz="1400" dirty="0">
                 <a:solidFill>
                   <a:srgbClr val="FFFFFF"/>
                 </a:solidFill>
                 <a:latin typeface="Calibri"/>
               </a:rPr>
-              <a:t>[completar]</a:t>
-            </a:r>
+              <a:t>140</a:t>
+            </a:r>
+            <a:endParaRPr sz="1400" b="0" i="0" dirty="0">
+              <a:solidFill>
+                <a:srgbClr val="FFFFFF"/>
+              </a:solidFill>
+              <a:latin typeface="Calibri"/>
+            </a:endParaRPr>
+          </a:p>
+          <a:p>
+            <a:pPr>
+              <a:spcAft>
+                <a:spcPts val="500"/>
+              </a:spcAft>
+            </a:pPr>
+            <a:r>
+              <a:rPr sz="1400" b="1" i="0" dirty="0" err="1">
+                <a:solidFill>
+                  <a:srgbClr val="E09F2C"/>
+                </a:solidFill>
+                <a:latin typeface="Calibri"/>
+              </a:rPr>
+              <a:t>Integrantes</a:t>
+            </a:r>
+            <a:r>
+              <a:rPr sz="1400" b="1" i="0" dirty="0">
+                <a:solidFill>
+                  <a:srgbClr val="E09F2C"/>
+                </a:solidFill>
+                <a:latin typeface="Calibri"/>
+              </a:rPr>
+              <a:t>:  </a:t>
+            </a:r>
+            <a:r>
+              <a:rPr lang="es-CO" sz="1400" b="0" i="0" dirty="0">
+                <a:solidFill>
+                  <a:srgbClr val="FFFFFF"/>
+                </a:solidFill>
+                <a:latin typeface="Calibri"/>
+              </a:rPr>
+              <a:t>Alexander Tapias </a:t>
+            </a:r>
+            <a:r>
+              <a:rPr sz="1400" b="0" i="0" dirty="0">
+                <a:solidFill>
+                  <a:srgbClr val="FFFFFF"/>
+                </a:solidFill>
+                <a:latin typeface="Calibri"/>
+              </a:rPr>
+              <a:t>· </a:t>
+            </a:r>
+            <a:r>
+              <a:rPr lang="es-CO" sz="1400" b="0" i="0" dirty="0">
+                <a:solidFill>
+                  <a:srgbClr val="FFFFFF"/>
+                </a:solidFill>
+                <a:latin typeface="Calibri"/>
+              </a:rPr>
+              <a:t>Estefanía Garcés</a:t>
+            </a:r>
+            <a:r>
+              <a:rPr sz="1400" b="0" i="0" dirty="0">
+                <a:solidFill>
+                  <a:srgbClr val="FFFFFF"/>
+                </a:solidFill>
+                <a:latin typeface="Calibri"/>
+              </a:rPr>
+              <a:t> · </a:t>
+            </a:r>
+            <a:r>
+              <a:rPr lang="es-CO" sz="1400" dirty="0">
+                <a:solidFill>
+                  <a:srgbClr val="FFFFFF"/>
+                </a:solidFill>
+              </a:rPr>
+              <a:t>Francisco Borrero · Juan Pablo Gómez</a:t>
+            </a:r>
+            <a:endParaRPr sz="1400" b="0" i="0" dirty="0">
+              <a:solidFill>
+                <a:srgbClr val="FFFFFF"/>
+              </a:solidFill>
+              <a:latin typeface="Calibri"/>
+            </a:endParaRPr>
           </a:p>
           <a:p>
             <a:pPr algn="l">
@@ -3486,22 +3598,49 @@
               </a:spcAft>
             </a:pPr>
             <a:r>
-              <a:rPr sz="1400" b="1" i="0">
+              <a:rPr sz="1400" b="1" i="0" dirty="0" err="1">
                 <a:solidFill>
                   <a:srgbClr val="E09F2C"/>
                 </a:solidFill>
                 <a:latin typeface="Calibri"/>
               </a:rPr>
-              <a:t>Integrantes:  </a:t>
-            </a:r>
-            <a:r>
-              <a:rPr sz="1400" b="0" i="0">
+              <a:t>Institución</a:t>
+            </a:r>
+            <a:r>
+              <a:rPr sz="1400" b="1" i="0" dirty="0">
+                <a:solidFill>
+                  <a:srgbClr val="E09F2C"/>
+                </a:solidFill>
+                <a:latin typeface="Calibri"/>
+              </a:rPr>
+              <a:t>:  </a:t>
+            </a:r>
+            <a:r>
+              <a:rPr sz="1400" b="0" i="0" dirty="0">
                 <a:solidFill>
                   <a:srgbClr val="FFFFFF"/>
                 </a:solidFill>
                 <a:latin typeface="Calibri"/>
               </a:rPr>
-              <a:t>[Nombre 1] · [Nombre 2] · [Nombre 3]</a:t>
+              <a:t>[Universidad / </a:t>
+            </a:r>
+            <a:r>
+              <a:rPr sz="1400" b="0" i="0" dirty="0" err="1">
+                <a:solidFill>
+                  <a:srgbClr val="FFFFFF"/>
+                </a:solidFill>
+                <a:latin typeface="Calibri"/>
+              </a:rPr>
+              <a:t>entidad</a:t>
+            </a:r>
+            <a:r>
+              <a:rPr sz="1400" b="0" i="0" dirty="0">
+                <a:solidFill>
+                  <a:srgbClr val="FFFFFF"/>
+                </a:solidFill>
+                <a:latin typeface="Calibri"/>
+              </a:rPr>
+              <a:t>]</a:t>
             </a:r>
           </a:p>
           <a:p>
@@ -3511,47 +3650,76 @@
               </a:spcAft>
             </a:pPr>
             <a:r>
-              <a:rPr sz="1400" b="1" i="0">
+              <a:rPr sz="1400" b="1" i="0" dirty="0" err="1">
                 <a:solidFill>
                   <a:srgbClr val="E09F2C"/>
                 </a:solidFill>
                 <a:latin typeface="Calibri"/>
               </a:rPr>
-              <a:t>Institución:  </a:t>
-            </a:r>
-            <a:r>
-              <a:rPr sz="1400" b="0" i="0">
+              <a:t>Fecha</a:t>
+            </a:r>
+            <a:r>
+              <a:rPr sz="1400" b="1" i="0" dirty="0">
+                <a:solidFill>
+                  <a:srgbClr val="E09F2C"/>
+                </a:solidFill>
+                <a:latin typeface="Calibri"/>
+              </a:rPr>
+              <a:t> de </a:t>
+            </a:r>
+            <a:r>
+              <a:rPr sz="1400" b="1" i="0" dirty="0" err="1">
+                <a:solidFill>
+                  <a:srgbClr val="E09F2C"/>
+                </a:solidFill>
+                <a:latin typeface="Calibri"/>
+              </a:rPr>
+              <a:t>sustentación</a:t>
+            </a:r>
+            <a:r>
+              <a:rPr sz="1400" b="1" i="0" dirty="0">
+                <a:solidFill>
+                  <a:srgbClr val="E09F2C"/>
+                </a:solidFill>
+                <a:latin typeface="Calibri"/>
+              </a:rPr>
+              <a:t>:  </a:t>
+            </a:r>
+            <a:r>
+              <a:rPr lang="es-CO" sz="1400" dirty="0">
                 <a:solidFill>
                   <a:srgbClr val="FFFFFF"/>
                 </a:solidFill>
                 <a:latin typeface="Calibri"/>
               </a:rPr>
-              <a:t>[Universidad / entidad]</a:t>
-            </a:r>
-          </a:p>
-          <a:p>
-            <a:pPr algn="l">
-              <a:spcAft>
-                <a:spcPts val="500"/>
-              </a:spcAft>
-            </a:pPr>
-            <a:r>
-              <a:rPr sz="1400" b="1" i="0">
-                <a:solidFill>
-                  <a:srgbClr val="E09F2C"/>
-                </a:solidFill>
-                <a:latin typeface="Calibri"/>
-              </a:rPr>
-              <a:t>Fecha de sustentación:  </a:t>
-            </a:r>
-            <a:r>
-              <a:rPr sz="1400" b="0" i="0">
+              <a:t>22</a:t>
+            </a:r>
+            <a:r>
+              <a:rPr sz="1400" b="0" i="0" dirty="0">
                 <a:solidFill>
                   <a:srgbClr val="FFFFFF"/>
                 </a:solidFill>
                 <a:latin typeface="Calibri"/>
               </a:rPr>
-              <a:t>[dd/mm/2026]</a:t>
+              <a:t>/</a:t>
+            </a:r>
+            <a:r>
+              <a:rPr lang="es-CO" sz="1400" dirty="0">
+                <a:solidFill>
+                  <a:srgbClr val="FFFFFF"/>
+                </a:solidFill>
+                <a:latin typeface="Calibri"/>
+              </a:rPr>
+              <a:t>07</a:t>
+            </a:r>
+            <a:r>
+              <a:rPr sz="1400" b="0" i="0" dirty="0">
+                <a:solidFill>
+                  <a:srgbClr val="FFFFFF"/>
+                </a:solidFill>
+                <a:latin typeface="Calibri"/>
+              </a:rPr>
+              <a:t>/2026</a:t>
             </a:r>
           </a:p>
         </p:txBody>
@@ -3573,7 +3741,7 @@
           <a:noFill/>
         </p:spPr>
         <p:txBody>
-          <a:bodyPr wrap="square" anchor="t" lIns="0" rIns="0" tIns="0" bIns="0">
+          <a:bodyPr wrap="square" lIns="0" tIns="0" rIns="0" bIns="0" anchor="t">
             <a:spAutoFit/>
           </a:bodyPr>
           <a:lstStyle/>
@@ -3600,7 +3768,7 @@
 </file>
 
 <file path=ppt/slides/slide10.xml><?xml version="1.0" encoding="utf-8"?>
-<p:sld xmlns:a="http://schemas.openxmlformats.org/drawingml/2006/main" xmlns:p="http://schemas.openxmlformats.org/presentationml/2006/main" xmlns:r="http://schemas.openxmlformats.org/officeDocument/2006/relationships">
+<p:sld xmlns:a="http://schemas.openxmlformats.org/drawingml/2006/main" xmlns:r="http://schemas.openxmlformats.org/officeDocument/2006/relationships" xmlns:p="http://schemas.openxmlformats.org/presentationml/2006/main">
   <p:cSld>
     <p:spTree>
       <p:nvGrpSpPr>
@@ -3608,7 +3776,14 @@
         <p:cNvGrpSpPr/>
         <p:nvPr/>
       </p:nvGrpSpPr>
-      <p:grpSpPr/>
+      <p:grpSpPr>
+        <a:xfrm>
+          <a:off x="0" y="0"/>
+          <a:ext cx="0" cy="0"/>
+          <a:chOff x="0" y="0"/>
+          <a:chExt cx="0" cy="0"/>
+        </a:xfrm>
+      </p:grpSpPr>
       <p:sp>
         <p:nvSpPr>
           <p:cNvPr id="2" name="Rectangle 1"/>
@@ -3650,6 +3825,7 @@
           <a:lstStyle/>
           <a:p>
             <a:pPr algn="ctr"/>
+            <a:endParaRPr/>
           </a:p>
         </p:txBody>
       </p:sp>
@@ -3694,6 +3870,7 @@
           <a:lstStyle/>
           <a:p>
             <a:pPr algn="ctr"/>
+            <a:endParaRPr/>
           </a:p>
         </p:txBody>
       </p:sp>
@@ -3738,6 +3915,7 @@
           <a:lstStyle/>
           <a:p>
             <a:pPr algn="ctr"/>
+            <a:endParaRPr/>
           </a:p>
         </p:txBody>
       </p:sp>
@@ -3758,7 +3936,7 @@
           <a:noFill/>
         </p:spPr>
         <p:txBody>
-          <a:bodyPr wrap="square" anchor="t" lIns="0" rIns="0" tIns="0" bIns="0">
+          <a:bodyPr wrap="square" lIns="0" tIns="0" rIns="0" bIns="0" anchor="t">
             <a:spAutoFit/>
           </a:bodyPr>
           <a:lstStyle/>
@@ -3793,7 +3971,7 @@
           <a:noFill/>
         </p:spPr>
         <p:txBody>
-          <a:bodyPr wrap="square" anchor="t" lIns="0" rIns="0" tIns="0" bIns="0">
+          <a:bodyPr wrap="square" lIns="0" tIns="0" rIns="0" bIns="0" anchor="t">
             <a:spAutoFit/>
           </a:bodyPr>
           <a:lstStyle/>
@@ -3844,7 +4022,7 @@
           <a:noFill/>
         </p:spPr>
         <p:txBody>
-          <a:bodyPr wrap="square" anchor="t" lIns="0" rIns="0" tIns="0" bIns="0">
+          <a:bodyPr wrap="square" lIns="0" tIns="0" rIns="0" bIns="0" anchor="t">
             <a:spAutoFit/>
           </a:bodyPr>
           <a:lstStyle/>
@@ -3977,6 +4155,7 @@
           <a:lstStyle/>
           <a:p>
             <a:pPr algn="ctr"/>
+            <a:endParaRPr/>
           </a:p>
         </p:txBody>
       </p:sp>
@@ -4021,6 +4200,7 @@
           <a:lstStyle/>
           <a:p>
             <a:pPr algn="ctr"/>
+            <a:endParaRPr/>
           </a:p>
         </p:txBody>
       </p:sp>
@@ -4041,7 +4221,7 @@
           <a:noFill/>
         </p:spPr>
         <p:txBody>
-          <a:bodyPr wrap="square" anchor="ctr" lIns="0" rIns="0" tIns="0" bIns="0">
+          <a:bodyPr wrap="square" lIns="0" tIns="0" rIns="0" bIns="0" anchor="ctr">
             <a:spAutoFit/>
           </a:bodyPr>
           <a:lstStyle/>
@@ -4068,7 +4248,7 @@
 </file>
 
 <file path=ppt/slides/slide2.xml><?xml version="1.0" encoding="utf-8"?>
-<p:sld xmlns:a="http://schemas.openxmlformats.org/drawingml/2006/main" xmlns:p="http://schemas.openxmlformats.org/presentationml/2006/main" xmlns:r="http://schemas.openxmlformats.org/officeDocument/2006/relationships">
+<p:sld xmlns:a="http://schemas.openxmlformats.org/drawingml/2006/main" xmlns:r="http://schemas.openxmlformats.org/officeDocument/2006/relationships" xmlns:p="http://schemas.openxmlformats.org/presentationml/2006/main">
   <p:cSld>
     <p:spTree>
       <p:nvGrpSpPr>
@@ -4076,7 +4256,14 @@
         <p:cNvGrpSpPr/>
         <p:nvPr/>
       </p:nvGrpSpPr>
-      <p:grpSpPr/>
+      <p:grpSpPr>
+        <a:xfrm>
+          <a:off x="0" y="0"/>
+          <a:ext cx="0" cy="0"/>
+          <a:chOff x="0" y="0"/>
+          <a:chExt cx="0" cy="0"/>
+        </a:xfrm>
+      </p:grpSpPr>
       <p:sp>
         <p:nvSpPr>
           <p:cNvPr id="2" name="Rectangle 1"/>
@@ -4118,6 +4305,7 @@
           <a:lstStyle/>
           <a:p>
             <a:pPr algn="ctr"/>
+            <a:endParaRPr/>
           </a:p>
         </p:txBody>
       </p:sp>
@@ -4162,6 +4350,7 @@
           <a:lstStyle/>
           <a:p>
             <a:pPr algn="ctr"/>
+            <a:endParaRPr/>
           </a:p>
         </p:txBody>
       </p:sp>
@@ -4206,6 +4395,7 @@
           <a:lstStyle/>
           <a:p>
             <a:pPr algn="ctr"/>
+            <a:endParaRPr/>
           </a:p>
         </p:txBody>
       </p:sp>
@@ -4226,7 +4416,7 @@
           <a:noFill/>
         </p:spPr>
         <p:txBody>
-          <a:bodyPr wrap="square" anchor="t" lIns="0" rIns="0" tIns="0" bIns="0">
+          <a:bodyPr wrap="square" lIns="0" tIns="0" rIns="0" bIns="0" anchor="t">
             <a:spAutoFit/>
           </a:bodyPr>
           <a:lstStyle/>
@@ -4261,7 +4451,7 @@
           <a:noFill/>
         </p:spPr>
         <p:txBody>
-          <a:bodyPr wrap="square" anchor="ctr" lIns="0" rIns="0" tIns="0" bIns="0">
+          <a:bodyPr wrap="square" lIns="0" tIns="0" rIns="0" bIns="0" anchor="ctr">
             <a:spAutoFit/>
           </a:bodyPr>
           <a:lstStyle/>
@@ -4296,7 +4486,7 @@
           <a:noFill/>
         </p:spPr>
         <p:txBody>
-          <a:bodyPr wrap="square" anchor="ctr" lIns="0" rIns="0" tIns="0" bIns="0">
+          <a:bodyPr wrap="square" lIns="0" tIns="0" rIns="0" bIns="0" anchor="ctr">
             <a:spAutoFit/>
           </a:bodyPr>
           <a:lstStyle/>
@@ -4355,6 +4545,7 @@
           <a:lstStyle/>
           <a:p>
             <a:pPr algn="ctr"/>
+            <a:endParaRPr/>
           </a:p>
         </p:txBody>
       </p:sp>
@@ -4375,7 +4566,7 @@
           <a:noFill/>
         </p:spPr>
         <p:txBody>
-          <a:bodyPr wrap="square" anchor="ctr" lIns="0" rIns="0" tIns="0" bIns="0">
+          <a:bodyPr wrap="square" lIns="0" tIns="0" rIns="0" bIns="0" anchor="ctr">
             <a:spAutoFit/>
           </a:bodyPr>
           <a:lstStyle/>
@@ -4410,7 +4601,7 @@
           <a:noFill/>
         </p:spPr>
         <p:txBody>
-          <a:bodyPr wrap="square" anchor="ctr" lIns="0" rIns="0" tIns="0" bIns="0">
+          <a:bodyPr wrap="square" lIns="0" tIns="0" rIns="0" bIns="0" anchor="ctr">
             <a:spAutoFit/>
           </a:bodyPr>
           <a:lstStyle/>
@@ -4471,6 +4662,7 @@
           <a:lstStyle/>
           <a:p>
             <a:pPr algn="ctr"/>
+            <a:endParaRPr/>
           </a:p>
         </p:txBody>
       </p:sp>
@@ -4515,6 +4707,7 @@
           <a:lstStyle/>
           <a:p>
             <a:pPr algn="ctr"/>
+            <a:endParaRPr/>
           </a:p>
         </p:txBody>
       </p:sp>
@@ -4535,7 +4728,7 @@
           <a:noFill/>
         </p:spPr>
         <p:txBody>
-          <a:bodyPr wrap="square" anchor="t" lIns="0" rIns="0" tIns="0" bIns="0">
+          <a:bodyPr wrap="square" lIns="0" tIns="0" rIns="0" bIns="0" anchor="t">
             <a:spAutoFit/>
           </a:bodyPr>
           <a:lstStyle/>
@@ -4570,7 +4763,7 @@
           <a:noFill/>
         </p:spPr>
         <p:txBody>
-          <a:bodyPr wrap="square" anchor="t" lIns="0" rIns="0" tIns="0" bIns="0">
+          <a:bodyPr wrap="square" lIns="0" tIns="0" rIns="0" bIns="0" anchor="t">
             <a:spAutoFit/>
           </a:bodyPr>
           <a:lstStyle/>
@@ -4703,6 +4896,7 @@
           <a:lstStyle/>
           <a:p>
             <a:pPr algn="ctr"/>
+            <a:endParaRPr/>
           </a:p>
         </p:txBody>
       </p:sp>
@@ -4747,6 +4941,7 @@
           <a:lstStyle/>
           <a:p>
             <a:pPr algn="ctr"/>
+            <a:endParaRPr/>
           </a:p>
         </p:txBody>
       </p:sp>
@@ -4767,7 +4962,7 @@
           <a:noFill/>
         </p:spPr>
         <p:txBody>
-          <a:bodyPr wrap="square" anchor="t" lIns="0" rIns="0" tIns="0" bIns="0">
+          <a:bodyPr wrap="square" lIns="0" tIns="0" rIns="0" bIns="0" anchor="t">
             <a:spAutoFit/>
           </a:bodyPr>
           <a:lstStyle/>
@@ -4802,7 +4997,7 @@
           <a:noFill/>
         </p:spPr>
         <p:txBody>
-          <a:bodyPr wrap="square" anchor="t" lIns="0" rIns="0" tIns="0" bIns="0">
+          <a:bodyPr wrap="square" lIns="0" tIns="0" rIns="0" bIns="0" anchor="t">
             <a:spAutoFit/>
           </a:bodyPr>
           <a:lstStyle/>
@@ -4935,6 +5130,7 @@
           <a:lstStyle/>
           <a:p>
             <a:pPr algn="ctr"/>
+            <a:endParaRPr/>
           </a:p>
         </p:txBody>
       </p:sp>
@@ -4955,7 +5151,7 @@
           <a:noFill/>
         </p:spPr>
         <p:txBody>
-          <a:bodyPr wrap="square" anchor="ctr" lIns="0" rIns="0" tIns="0" bIns="0">
+          <a:bodyPr wrap="square" lIns="0" tIns="0" rIns="0" bIns="0" anchor="ctr">
             <a:spAutoFit/>
           </a:bodyPr>
           <a:lstStyle/>
@@ -4998,7 +5194,7 @@
 </file>
 
 <file path=ppt/slides/slide3.xml><?xml version="1.0" encoding="utf-8"?>
-<p:sld xmlns:a="http://schemas.openxmlformats.org/drawingml/2006/main" xmlns:p="http://schemas.openxmlformats.org/presentationml/2006/main" xmlns:r="http://schemas.openxmlformats.org/officeDocument/2006/relationships">
+<p:sld xmlns:a="http://schemas.openxmlformats.org/drawingml/2006/main" xmlns:r="http://schemas.openxmlformats.org/officeDocument/2006/relationships" xmlns:p="http://schemas.openxmlformats.org/presentationml/2006/main">
   <p:cSld>
     <p:spTree>
       <p:nvGrpSpPr>
@@ -5006,7 +5202,14 @@
         <p:cNvGrpSpPr/>
         <p:nvPr/>
       </p:nvGrpSpPr>
-      <p:grpSpPr/>
+      <p:grpSpPr>
+        <a:xfrm>
+          <a:off x="0" y="0"/>
+          <a:ext cx="0" cy="0"/>
+          <a:chOff x="0" y="0"/>
+          <a:chExt cx="0" cy="0"/>
+        </a:xfrm>
+      </p:grpSpPr>
       <p:sp>
         <p:nvSpPr>
           <p:cNvPr id="2" name="Rectangle 1"/>
@@ -5048,6 +5251,7 @@
           <a:lstStyle/>
           <a:p>
             <a:pPr algn="ctr"/>
+            <a:endParaRPr/>
           </a:p>
         </p:txBody>
       </p:sp>
@@ -5092,6 +5296,7 @@
           <a:lstStyle/>
           <a:p>
             <a:pPr algn="ctr"/>
+            <a:endParaRPr/>
           </a:p>
         </p:txBody>
       </p:sp>
@@ -5136,6 +5341,7 @@
           <a:lstStyle/>
           <a:p>
             <a:pPr algn="ctr"/>
+            <a:endParaRPr/>
           </a:p>
         </p:txBody>
       </p:sp>
@@ -5156,7 +5362,7 @@
           <a:noFill/>
         </p:spPr>
         <p:txBody>
-          <a:bodyPr wrap="square" anchor="t" lIns="0" rIns="0" tIns="0" bIns="0">
+          <a:bodyPr wrap="square" lIns="0" tIns="0" rIns="0" bIns="0" anchor="t">
             <a:spAutoFit/>
           </a:bodyPr>
           <a:lstStyle/>
@@ -5191,7 +5397,7 @@
           <a:noFill/>
         </p:spPr>
         <p:txBody>
-          <a:bodyPr wrap="square" anchor="ctr" lIns="0" rIns="0" tIns="0" bIns="0">
+          <a:bodyPr wrap="square" lIns="0" tIns="0" rIns="0" bIns="0" anchor="ctr">
             <a:spAutoFit/>
           </a:bodyPr>
           <a:lstStyle/>
@@ -5226,7 +5432,7 @@
           <a:noFill/>
         </p:spPr>
         <p:txBody>
-          <a:bodyPr wrap="square" anchor="ctr" lIns="0" rIns="0" tIns="0" bIns="0">
+          <a:bodyPr wrap="square" lIns="0" tIns="0" rIns="0" bIns="0" anchor="ctr">
             <a:spAutoFit/>
           </a:bodyPr>
           <a:lstStyle/>
@@ -5285,6 +5491,7 @@
           <a:lstStyle/>
           <a:p>
             <a:pPr algn="ctr"/>
+            <a:endParaRPr/>
           </a:p>
         </p:txBody>
       </p:sp>
@@ -5305,7 +5512,7 @@
           <a:noFill/>
         </p:spPr>
         <p:txBody>
-          <a:bodyPr wrap="square" anchor="ctr" lIns="0" rIns="0" tIns="0" bIns="0">
+          <a:bodyPr wrap="square" lIns="0" tIns="0" rIns="0" bIns="0" anchor="ctr">
             <a:spAutoFit/>
           </a:bodyPr>
           <a:lstStyle/>
@@ -5340,7 +5547,7 @@
           <a:noFill/>
         </p:spPr>
         <p:txBody>
-          <a:bodyPr wrap="square" anchor="ctr" lIns="0" rIns="0" tIns="0" bIns="0">
+          <a:bodyPr wrap="square" lIns="0" tIns="0" rIns="0" bIns="0" anchor="ctr">
             <a:spAutoFit/>
           </a:bodyPr>
           <a:lstStyle/>
@@ -5377,9 +5584,27 @@
                 <a:tableStyleId>{5C22544A-7EE6-4342-B048-85BDC9FD1C3A}</a:tableStyleId>
               </a:tblPr>
               <a:tblGrid>
-                <a:gridCol w="3977639"/>
-                <a:gridCol w="2514600"/>
-                <a:gridCol w="914400"/>
+                <a:gridCol w="3977639">
+                  <a:extLst>
+                    <a:ext uri="{9D8B030D-6E8A-4147-A177-3AD203B41FA5}">
+                      <a16:colId xmlns:a16="http://schemas.microsoft.com/office/drawing/2014/main" val="20000"/>
+                    </a:ext>
+                  </a:extLst>
+                </a:gridCol>
+                <a:gridCol w="2514600">
+                  <a:extLst>
+                    <a:ext uri="{9D8B030D-6E8A-4147-A177-3AD203B41FA5}">
+                      <a16:colId xmlns:a16="http://schemas.microsoft.com/office/drawing/2014/main" val="20001"/>
+                    </a:ext>
+                  </a:extLst>
+                </a:gridCol>
+                <a:gridCol w="914400">
+                  <a:extLst>
+                    <a:ext uri="{9D8B030D-6E8A-4147-A177-3AD203B41FA5}">
+                      <a16:colId xmlns:a16="http://schemas.microsoft.com/office/drawing/2014/main" val="20002"/>
+                    </a:ext>
+                  </a:extLst>
+                </a:gridCol>
               </a:tblGrid>
               <a:tr h="563880">
                 <a:tc>
@@ -5399,7 +5624,7 @@
                       </a:r>
                     </a:p>
                   </a:txBody>
-                  <a:tcPr marL="91440" marR="54864" marT="27432" marB="27432" anchor="ctr">
+                  <a:tcPr marR="54864" marT="27432" marB="27432" anchor="ctr">
                     <a:solidFill>
                       <a:srgbClr val="0B3C5D"/>
                     </a:solidFill>
@@ -5422,7 +5647,7 @@
                       </a:r>
                     </a:p>
                   </a:txBody>
-                  <a:tcPr marL="91440" marR="54864" marT="27432" marB="27432" anchor="ctr">
+                  <a:tcPr marR="54864" marT="27432" marB="27432" anchor="ctr">
                     <a:solidFill>
                       <a:srgbClr val="0B3C5D"/>
                     </a:solidFill>
@@ -5445,12 +5670,17 @@
                       </a:r>
                     </a:p>
                   </a:txBody>
-                  <a:tcPr marL="91440" marR="54864" marT="27432" marB="27432" anchor="ctr">
+                  <a:tcPr marR="54864" marT="27432" marB="27432" anchor="ctr">
                     <a:solidFill>
                       <a:srgbClr val="0B3C5D"/>
                     </a:solidFill>
                   </a:tcPr>
                 </a:tc>
+                <a:extLst>
+                  <a:ext uri="{0D108BD9-81ED-4DB2-BD59-A6C34878D82A}">
+                    <a16:rowId xmlns:a16="http://schemas.microsoft.com/office/drawing/2014/main" val="10000"/>
+                  </a:ext>
+                </a:extLst>
               </a:tr>
               <a:tr h="563880">
                 <a:tc>
@@ -5470,7 +5700,7 @@
                       </a:r>
                     </a:p>
                   </a:txBody>
-                  <a:tcPr marL="91440" marR="54864" marT="27432" marB="27432" anchor="ctr">
+                  <a:tcPr marR="54864" marT="27432" marB="27432" anchor="ctr">
                     <a:solidFill>
                       <a:srgbClr val="F5F7FA"/>
                     </a:solidFill>
@@ -5493,7 +5723,7 @@
                       </a:r>
                     </a:p>
                   </a:txBody>
-                  <a:tcPr marL="91440" marR="54864" marT="27432" marB="27432" anchor="ctr">
+                  <a:tcPr marR="54864" marT="27432" marB="27432" anchor="ctr">
                     <a:solidFill>
                       <a:srgbClr val="F5F7FA"/>
                     </a:solidFill>
@@ -5516,12 +5746,17 @@
                       </a:r>
                     </a:p>
                   </a:txBody>
-                  <a:tcPr marL="91440" marR="54864" marT="27432" marB="27432" anchor="ctr">
+                  <a:tcPr marR="54864" marT="27432" marB="27432" anchor="ctr">
                     <a:solidFill>
                       <a:srgbClr val="F5F7FA"/>
                     </a:solidFill>
                   </a:tcPr>
                 </a:tc>
+                <a:extLst>
+                  <a:ext uri="{0D108BD9-81ED-4DB2-BD59-A6C34878D82A}">
+                    <a16:rowId xmlns:a16="http://schemas.microsoft.com/office/drawing/2014/main" val="10001"/>
+                  </a:ext>
+                </a:extLst>
               </a:tr>
               <a:tr h="563880">
                 <a:tc>
@@ -5541,7 +5776,7 @@
                       </a:r>
                     </a:p>
                   </a:txBody>
-                  <a:tcPr marL="91440" marR="54864" marT="27432" marB="27432" anchor="ctr">
+                  <a:tcPr marR="54864" marT="27432" marB="27432" anchor="ctr">
                     <a:solidFill>
                       <a:srgbClr val="FFFFFF"/>
                     </a:solidFill>
@@ -5564,7 +5799,7 @@
                       </a:r>
                     </a:p>
                   </a:txBody>
-                  <a:tcPr marL="91440" marR="54864" marT="27432" marB="27432" anchor="ctr">
+                  <a:tcPr marR="54864" marT="27432" marB="27432" anchor="ctr">
                     <a:solidFill>
                       <a:srgbClr val="FFFFFF"/>
                     </a:solidFill>
@@ -5587,12 +5822,17 @@
                       </a:r>
                     </a:p>
                   </a:txBody>
-                  <a:tcPr marL="91440" marR="54864" marT="27432" marB="27432" anchor="ctr">
+                  <a:tcPr marR="54864" marT="27432" marB="27432" anchor="ctr">
                     <a:solidFill>
                       <a:srgbClr val="FFFFFF"/>
                     </a:solidFill>
                   </a:tcPr>
                 </a:tc>
+                <a:extLst>
+                  <a:ext uri="{0D108BD9-81ED-4DB2-BD59-A6C34878D82A}">
+                    <a16:rowId xmlns:a16="http://schemas.microsoft.com/office/drawing/2014/main" val="10002"/>
+                  </a:ext>
+                </a:extLst>
               </a:tr>
               <a:tr h="563880">
                 <a:tc>
@@ -5612,7 +5852,7 @@
                       </a:r>
                     </a:p>
                   </a:txBody>
-                  <a:tcPr marL="91440" marR="54864" marT="27432" marB="27432" anchor="ctr">
+                  <a:tcPr marR="54864" marT="27432" marB="27432" anchor="ctr">
                     <a:solidFill>
                       <a:srgbClr val="F5F7FA"/>
                     </a:solidFill>
@@ -5635,7 +5875,7 @@
                       </a:r>
                     </a:p>
                   </a:txBody>
-                  <a:tcPr marL="91440" marR="54864" marT="27432" marB="27432" anchor="ctr">
+                  <a:tcPr marR="54864" marT="27432" marB="27432" anchor="ctr">
                     <a:solidFill>
                       <a:srgbClr val="F5F7FA"/>
                     </a:solidFill>
@@ -5658,12 +5898,17 @@
                       </a:r>
                     </a:p>
                   </a:txBody>
-                  <a:tcPr marL="91440" marR="54864" marT="27432" marB="27432" anchor="ctr">
+                  <a:tcPr marR="54864" marT="27432" marB="27432" anchor="ctr">
                     <a:solidFill>
                       <a:srgbClr val="F5F7FA"/>
                     </a:solidFill>
                   </a:tcPr>
                 </a:tc>
+                <a:extLst>
+                  <a:ext uri="{0D108BD9-81ED-4DB2-BD59-A6C34878D82A}">
+                    <a16:rowId xmlns:a16="http://schemas.microsoft.com/office/drawing/2014/main" val="10003"/>
+                  </a:ext>
+                </a:extLst>
               </a:tr>
               <a:tr h="563880">
                 <a:tc>
@@ -5683,7 +5928,7 @@
                       </a:r>
                     </a:p>
                   </a:txBody>
-                  <a:tcPr marL="91440" marR="54864" marT="27432" marB="27432" anchor="ctr">
+                  <a:tcPr marR="54864" marT="27432" marB="27432" anchor="ctr">
                     <a:solidFill>
                       <a:srgbClr val="FFFFFF"/>
                     </a:solidFill>
@@ -5706,7 +5951,7 @@
                       </a:r>
                     </a:p>
                   </a:txBody>
-                  <a:tcPr marL="91440" marR="54864" marT="27432" marB="27432" anchor="ctr">
+                  <a:tcPr marR="54864" marT="27432" marB="27432" anchor="ctr">
                     <a:solidFill>
                       <a:srgbClr val="FFFFFF"/>
                     </a:solidFill>
@@ -5729,12 +5974,17 @@
                       </a:r>
                     </a:p>
                   </a:txBody>
-                  <a:tcPr marL="91440" marR="54864" marT="27432" marB="27432" anchor="ctr">
+                  <a:tcPr marR="54864" marT="27432" marB="27432" anchor="ctr">
                     <a:solidFill>
                       <a:srgbClr val="FFFFFF"/>
                     </a:solidFill>
                   </a:tcPr>
                 </a:tc>
+                <a:extLst>
+                  <a:ext uri="{0D108BD9-81ED-4DB2-BD59-A6C34878D82A}">
+                    <a16:rowId xmlns:a16="http://schemas.microsoft.com/office/drawing/2014/main" val="10004"/>
+                  </a:ext>
+                </a:extLst>
               </a:tr>
               <a:tr h="563880">
                 <a:tc>
@@ -5754,7 +6004,7 @@
                       </a:r>
                     </a:p>
                   </a:txBody>
-                  <a:tcPr marL="91440" marR="54864" marT="27432" marB="27432" anchor="ctr">
+                  <a:tcPr marR="54864" marT="27432" marB="27432" anchor="ctr">
                     <a:solidFill>
                       <a:srgbClr val="F5F7FA"/>
                     </a:solidFill>
@@ -5777,7 +6027,7 @@
                       </a:r>
                     </a:p>
                   </a:txBody>
-                  <a:tcPr marL="91440" marR="54864" marT="27432" marB="27432" anchor="ctr">
+                  <a:tcPr marR="54864" marT="27432" marB="27432" anchor="ctr">
                     <a:solidFill>
                       <a:srgbClr val="F5F7FA"/>
                     </a:solidFill>
@@ -5800,12 +6050,17 @@
                       </a:r>
                     </a:p>
                   </a:txBody>
-                  <a:tcPr marL="91440" marR="54864" marT="27432" marB="27432" anchor="ctr">
+                  <a:tcPr marR="54864" marT="27432" marB="27432" anchor="ctr">
                     <a:solidFill>
                       <a:srgbClr val="F5F7FA"/>
                     </a:solidFill>
                   </a:tcPr>
                 </a:tc>
+                <a:extLst>
+                  <a:ext uri="{0D108BD9-81ED-4DB2-BD59-A6C34878D82A}">
+                    <a16:rowId xmlns:a16="http://schemas.microsoft.com/office/drawing/2014/main" val="10005"/>
+                  </a:ext>
+                </a:extLst>
               </a:tr>
             </a:tbl>
           </a:graphicData>
@@ -5854,6 +6109,7 @@
           <a:lstStyle/>
           <a:p>
             <a:pPr algn="ctr"/>
+            <a:endParaRPr/>
           </a:p>
         </p:txBody>
       </p:sp>
@@ -5898,6 +6154,7 @@
           <a:lstStyle/>
           <a:p>
             <a:pPr algn="ctr"/>
+            <a:endParaRPr/>
           </a:p>
         </p:txBody>
       </p:sp>
@@ -5918,7 +6175,7 @@
           <a:noFill/>
         </p:spPr>
         <p:txBody>
-          <a:bodyPr wrap="square" anchor="t" lIns="0" rIns="0" tIns="0" bIns="0">
+          <a:bodyPr wrap="square" lIns="0" tIns="0" rIns="0" bIns="0" anchor="t">
             <a:spAutoFit/>
           </a:bodyPr>
           <a:lstStyle/>
@@ -5953,7 +6210,7 @@
           <a:noFill/>
         </p:spPr>
         <p:txBody>
-          <a:bodyPr wrap="square" anchor="t" lIns="0" rIns="0" tIns="0" bIns="0">
+          <a:bodyPr wrap="square" lIns="0" tIns="0" rIns="0" bIns="0" anchor="t">
             <a:spAutoFit/>
           </a:bodyPr>
           <a:lstStyle/>
@@ -6114,6 +6371,7 @@
           <a:lstStyle/>
           <a:p>
             <a:pPr algn="ctr"/>
+            <a:endParaRPr/>
           </a:p>
         </p:txBody>
       </p:sp>
@@ -6134,7 +6392,7 @@
           <a:noFill/>
         </p:spPr>
         <p:txBody>
-          <a:bodyPr wrap="square" anchor="ctr" lIns="0" rIns="0" tIns="0" bIns="0">
+          <a:bodyPr wrap="square" lIns="0" tIns="0" rIns="0" bIns="0" anchor="ctr">
             <a:spAutoFit/>
           </a:bodyPr>
           <a:lstStyle/>
@@ -6169,7 +6427,7 @@
           <a:noFill/>
         </p:spPr>
         <p:txBody>
-          <a:bodyPr wrap="square" anchor="t" lIns="0" rIns="0" tIns="0" bIns="0">
+          <a:bodyPr wrap="square" lIns="0" tIns="0" rIns="0" bIns="0" anchor="t">
             <a:spAutoFit/>
           </a:bodyPr>
           <a:lstStyle/>
@@ -6230,6 +6488,7 @@
           <a:lstStyle/>
           <a:p>
             <a:pPr algn="ctr"/>
+            <a:endParaRPr/>
           </a:p>
         </p:txBody>
       </p:sp>
@@ -6250,7 +6509,7 @@
           <a:noFill/>
         </p:spPr>
         <p:txBody>
-          <a:bodyPr wrap="square" anchor="ctr" lIns="0" rIns="0" tIns="0" bIns="0">
+          <a:bodyPr wrap="square" lIns="0" tIns="0" rIns="0" bIns="0" anchor="ctr">
             <a:spAutoFit/>
           </a:bodyPr>
           <a:lstStyle/>
@@ -6285,7 +6544,7 @@
           <a:noFill/>
         </p:spPr>
         <p:txBody>
-          <a:bodyPr wrap="square" anchor="t" lIns="0" rIns="0" tIns="0" bIns="0">
+          <a:bodyPr wrap="square" lIns="0" tIns="0" rIns="0" bIns="0" anchor="t">
             <a:spAutoFit/>
           </a:bodyPr>
           <a:lstStyle/>
@@ -6346,6 +6605,7 @@
           <a:lstStyle/>
           <a:p>
             <a:pPr algn="ctr"/>
+            <a:endParaRPr/>
           </a:p>
         </p:txBody>
       </p:sp>
@@ -6366,7 +6626,7 @@
           <a:noFill/>
         </p:spPr>
         <p:txBody>
-          <a:bodyPr wrap="square" anchor="ctr" lIns="0" rIns="0" tIns="0" bIns="0">
+          <a:bodyPr wrap="square" lIns="0" tIns="0" rIns="0" bIns="0" anchor="ctr">
             <a:spAutoFit/>
           </a:bodyPr>
           <a:lstStyle/>
@@ -6401,7 +6661,7 @@
           <a:noFill/>
         </p:spPr>
         <p:txBody>
-          <a:bodyPr wrap="square" anchor="t" lIns="0" rIns="0" tIns="0" bIns="0">
+          <a:bodyPr wrap="square" lIns="0" tIns="0" rIns="0" bIns="0" anchor="t">
             <a:spAutoFit/>
           </a:bodyPr>
           <a:lstStyle/>
@@ -6428,7 +6688,7 @@
 </file>
 
 <file path=ppt/slides/slide4.xml><?xml version="1.0" encoding="utf-8"?>
-<p:sld xmlns:a="http://schemas.openxmlformats.org/drawingml/2006/main" xmlns:p="http://schemas.openxmlformats.org/presentationml/2006/main" xmlns:r="http://schemas.openxmlformats.org/officeDocument/2006/relationships">
+<p:sld xmlns:a="http://schemas.openxmlformats.org/drawingml/2006/main" xmlns:r="http://schemas.openxmlformats.org/officeDocument/2006/relationships" xmlns:p="http://schemas.openxmlformats.org/presentationml/2006/main">
   <p:cSld>
     <p:spTree>
       <p:nvGrpSpPr>
@@ -6436,7 +6696,14 @@
         <p:cNvGrpSpPr/>
         <p:nvPr/>
       </p:nvGrpSpPr>
-      <p:grpSpPr/>
+      <p:grpSpPr>
+        <a:xfrm>
+          <a:off x="0" y="0"/>
+          <a:ext cx="0" cy="0"/>
+          <a:chOff x="0" y="0"/>
+          <a:chExt cx="0" cy="0"/>
+        </a:xfrm>
+      </p:grpSpPr>
       <p:sp>
         <p:nvSpPr>
           <p:cNvPr id="2" name="Rectangle 1"/>
@@ -6478,6 +6745,7 @@
           <a:lstStyle/>
           <a:p>
             <a:pPr algn="ctr"/>
+            <a:endParaRPr/>
           </a:p>
         </p:txBody>
       </p:sp>
@@ -6522,6 +6790,7 @@
           <a:lstStyle/>
           <a:p>
             <a:pPr algn="ctr"/>
+            <a:endParaRPr/>
           </a:p>
         </p:txBody>
       </p:sp>
@@ -6566,6 +6835,7 @@
           <a:lstStyle/>
           <a:p>
             <a:pPr algn="ctr"/>
+            <a:endParaRPr/>
           </a:p>
         </p:txBody>
       </p:sp>
@@ -6586,7 +6856,7 @@
           <a:noFill/>
         </p:spPr>
         <p:txBody>
-          <a:bodyPr wrap="square" anchor="t" lIns="0" rIns="0" tIns="0" bIns="0">
+          <a:bodyPr wrap="square" lIns="0" tIns="0" rIns="0" bIns="0" anchor="t">
             <a:spAutoFit/>
           </a:bodyPr>
           <a:lstStyle/>
@@ -6621,7 +6891,7 @@
           <a:noFill/>
         </p:spPr>
         <p:txBody>
-          <a:bodyPr wrap="square" anchor="ctr" lIns="0" rIns="0" tIns="0" bIns="0">
+          <a:bodyPr wrap="square" lIns="0" tIns="0" rIns="0" bIns="0" anchor="ctr">
             <a:spAutoFit/>
           </a:bodyPr>
           <a:lstStyle/>
@@ -6656,7 +6926,7 @@
           <a:noFill/>
         </p:spPr>
         <p:txBody>
-          <a:bodyPr wrap="square" anchor="ctr" lIns="0" rIns="0" tIns="0" bIns="0">
+          <a:bodyPr wrap="square" lIns="0" tIns="0" rIns="0" bIns="0" anchor="ctr">
             <a:spAutoFit/>
           </a:bodyPr>
           <a:lstStyle/>
@@ -6715,6 +6985,7 @@
           <a:lstStyle/>
           <a:p>
             <a:pPr algn="ctr"/>
+            <a:endParaRPr/>
           </a:p>
         </p:txBody>
       </p:sp>
@@ -6735,7 +7006,7 @@
           <a:noFill/>
         </p:spPr>
         <p:txBody>
-          <a:bodyPr wrap="square" anchor="ctr" lIns="0" rIns="0" tIns="0" bIns="0">
+          <a:bodyPr wrap="square" lIns="0" tIns="0" rIns="0" bIns="0" anchor="ctr">
             <a:spAutoFit/>
           </a:bodyPr>
           <a:lstStyle/>
@@ -6770,7 +7041,7 @@
           <a:noFill/>
         </p:spPr>
         <p:txBody>
-          <a:bodyPr wrap="square" anchor="ctr" lIns="0" rIns="0" tIns="0" bIns="0">
+          <a:bodyPr wrap="square" lIns="0" tIns="0" rIns="0" bIns="0" anchor="ctr">
             <a:spAutoFit/>
           </a:bodyPr>
           <a:lstStyle/>
@@ -6831,6 +7102,7 @@
           <a:lstStyle/>
           <a:p>
             <a:pPr algn="ctr"/>
+            <a:endParaRPr/>
           </a:p>
         </p:txBody>
       </p:sp>
@@ -6851,7 +7123,7 @@
           <a:noFill/>
         </p:spPr>
         <p:txBody>
-          <a:bodyPr wrap="square" anchor="ctr" lIns="0" rIns="0" tIns="0" bIns="0">
+          <a:bodyPr wrap="square" lIns="0" tIns="0" rIns="0" bIns="0" anchor="ctr">
             <a:spAutoFit/>
           </a:bodyPr>
           <a:lstStyle/>
@@ -6886,7 +7158,7 @@
           <a:noFill/>
         </p:spPr>
         <p:txBody>
-          <a:bodyPr wrap="square" anchor="ctr" lIns="0" rIns="0" tIns="0" bIns="0">
+          <a:bodyPr wrap="square" lIns="0" tIns="0" rIns="0" bIns="0" anchor="ctr">
             <a:spAutoFit/>
           </a:bodyPr>
           <a:lstStyle/>
@@ -6947,6 +7219,7 @@
           <a:lstStyle/>
           <a:p>
             <a:pPr algn="ctr"/>
+            <a:endParaRPr/>
           </a:p>
         </p:txBody>
       </p:sp>
@@ -6967,7 +7240,7 @@
           <a:noFill/>
         </p:spPr>
         <p:txBody>
-          <a:bodyPr wrap="square" anchor="ctr" lIns="0" rIns="0" tIns="0" bIns="0">
+          <a:bodyPr wrap="square" lIns="0" tIns="0" rIns="0" bIns="0" anchor="ctr">
             <a:spAutoFit/>
           </a:bodyPr>
           <a:lstStyle/>
@@ -7002,7 +7275,7 @@
           <a:noFill/>
         </p:spPr>
         <p:txBody>
-          <a:bodyPr wrap="square" anchor="ctr" lIns="0" rIns="0" tIns="0" bIns="0">
+          <a:bodyPr wrap="square" lIns="0" tIns="0" rIns="0" bIns="0" anchor="ctr">
             <a:spAutoFit/>
           </a:bodyPr>
           <a:lstStyle/>
@@ -7063,6 +7336,7 @@
           <a:lstStyle/>
           <a:p>
             <a:pPr algn="ctr"/>
+            <a:endParaRPr/>
           </a:p>
         </p:txBody>
       </p:sp>
@@ -7083,7 +7357,7 @@
           <a:noFill/>
         </p:spPr>
         <p:txBody>
-          <a:bodyPr wrap="square" anchor="ctr" lIns="0" rIns="0" tIns="0" bIns="0">
+          <a:bodyPr wrap="square" lIns="0" tIns="0" rIns="0" bIns="0" anchor="ctr">
             <a:spAutoFit/>
           </a:bodyPr>
           <a:lstStyle/>
@@ -7118,7 +7392,7 @@
           <a:noFill/>
         </p:spPr>
         <p:txBody>
-          <a:bodyPr wrap="square" anchor="ctr" lIns="0" rIns="0" tIns="0" bIns="0">
+          <a:bodyPr wrap="square" lIns="0" tIns="0" rIns="0" bIns="0" anchor="ctr">
             <a:spAutoFit/>
           </a:bodyPr>
           <a:lstStyle/>
@@ -7179,6 +7453,7 @@
           <a:lstStyle/>
           <a:p>
             <a:pPr algn="ctr"/>
+            <a:endParaRPr/>
           </a:p>
         </p:txBody>
       </p:sp>
@@ -7199,7 +7474,7 @@
           <a:noFill/>
         </p:spPr>
         <p:txBody>
-          <a:bodyPr wrap="square" anchor="ctr" lIns="0" rIns="0" tIns="0" bIns="0">
+          <a:bodyPr wrap="square" lIns="0" tIns="0" rIns="0" bIns="0" anchor="ctr">
             <a:spAutoFit/>
           </a:bodyPr>
           <a:lstStyle/>
@@ -7234,7 +7509,7 @@
           <a:noFill/>
         </p:spPr>
         <p:txBody>
-          <a:bodyPr wrap="square" anchor="ctr" lIns="0" rIns="0" tIns="0" bIns="0">
+          <a:bodyPr wrap="square" lIns="0" tIns="0" rIns="0" bIns="0" anchor="ctr">
             <a:spAutoFit/>
           </a:bodyPr>
           <a:lstStyle/>
@@ -7295,6 +7570,7 @@
           <a:lstStyle/>
           <a:p>
             <a:pPr algn="ctr"/>
+            <a:endParaRPr/>
           </a:p>
         </p:txBody>
       </p:sp>
@@ -7339,6 +7615,7 @@
           <a:lstStyle/>
           <a:p>
             <a:pPr algn="ctr"/>
+            <a:endParaRPr/>
           </a:p>
         </p:txBody>
       </p:sp>
@@ -7359,7 +7636,7 @@
           <a:noFill/>
         </p:spPr>
         <p:txBody>
-          <a:bodyPr wrap="square" anchor="t" lIns="0" rIns="0" tIns="0" bIns="0">
+          <a:bodyPr wrap="square" lIns="0" tIns="0" rIns="0" bIns="0" anchor="t">
             <a:spAutoFit/>
           </a:bodyPr>
           <a:lstStyle/>
@@ -7406,7 +7683,7 @@
           <a:noFill/>
         </p:spPr>
         <p:txBody>
-          <a:bodyPr wrap="square" anchor="t" lIns="0" rIns="0" tIns="0" bIns="0">
+          <a:bodyPr wrap="square" lIns="0" tIns="0" rIns="0" bIns="0" anchor="t">
             <a:spAutoFit/>
           </a:bodyPr>
           <a:lstStyle/>
@@ -7539,6 +7816,7 @@
           <a:lstStyle/>
           <a:p>
             <a:pPr algn="ctr"/>
+            <a:endParaRPr/>
           </a:p>
         </p:txBody>
       </p:sp>
@@ -7583,6 +7861,7 @@
           <a:lstStyle/>
           <a:p>
             <a:pPr algn="ctr"/>
+            <a:endParaRPr/>
           </a:p>
         </p:txBody>
       </p:sp>
@@ -7603,7 +7882,7 @@
           <a:noFill/>
         </p:spPr>
         <p:txBody>
-          <a:bodyPr wrap="square" anchor="t" lIns="0" rIns="0" tIns="0" bIns="0">
+          <a:bodyPr wrap="square" lIns="0" tIns="0" rIns="0" bIns="0" anchor="t">
             <a:spAutoFit/>
           </a:bodyPr>
           <a:lstStyle/>
@@ -7650,7 +7929,7 @@
           <a:noFill/>
         </p:spPr>
         <p:txBody>
-          <a:bodyPr wrap="square" anchor="t" lIns="0" rIns="0" tIns="0" bIns="0">
+          <a:bodyPr wrap="square" lIns="0" tIns="0" rIns="0" bIns="0" anchor="t">
             <a:spAutoFit/>
           </a:bodyPr>
           <a:lstStyle/>
@@ -7783,6 +8062,7 @@
           <a:lstStyle/>
           <a:p>
             <a:pPr algn="ctr"/>
+            <a:endParaRPr/>
           </a:p>
         </p:txBody>
       </p:sp>
@@ -7803,7 +8083,7 @@
           <a:noFill/>
         </p:spPr>
         <p:txBody>
-          <a:bodyPr wrap="square" anchor="ctr" lIns="0" rIns="0" tIns="0" bIns="0">
+          <a:bodyPr wrap="square" lIns="0" tIns="0" rIns="0" bIns="0" anchor="ctr">
             <a:spAutoFit/>
           </a:bodyPr>
           <a:lstStyle/>
@@ -7830,7 +8110,7 @@
 </file>
 
 <file path=ppt/slides/slide5.xml><?xml version="1.0" encoding="utf-8"?>
-<p:sld xmlns:a="http://schemas.openxmlformats.org/drawingml/2006/main" xmlns:p="http://schemas.openxmlformats.org/presentationml/2006/main" xmlns:r="http://schemas.openxmlformats.org/officeDocument/2006/relationships">
+<p:sld xmlns:a="http://schemas.openxmlformats.org/drawingml/2006/main" xmlns:r="http://schemas.openxmlformats.org/officeDocument/2006/relationships" xmlns:p="http://schemas.openxmlformats.org/presentationml/2006/main">
   <p:cSld>
     <p:spTree>
       <p:nvGrpSpPr>
@@ -7838,7 +8118,14 @@
         <p:cNvGrpSpPr/>
         <p:nvPr/>
       </p:nvGrpSpPr>
-      <p:grpSpPr/>
+      <p:grpSpPr>
+        <a:xfrm>
+          <a:off x="0" y="0"/>
+          <a:ext cx="0" cy="0"/>
+          <a:chOff x="0" y="0"/>
+          <a:chExt cx="0" cy="0"/>
+        </a:xfrm>
+      </p:grpSpPr>
       <p:sp>
         <p:nvSpPr>
           <p:cNvPr id="2" name="Rectangle 1"/>
@@ -7880,6 +8167,7 @@
           <a:lstStyle/>
           <a:p>
             <a:pPr algn="ctr"/>
+            <a:endParaRPr/>
           </a:p>
         </p:txBody>
       </p:sp>
@@ -7924,6 +8212,7 @@
           <a:lstStyle/>
           <a:p>
             <a:pPr algn="ctr"/>
+            <a:endParaRPr/>
           </a:p>
         </p:txBody>
       </p:sp>
@@ -7968,6 +8257,7 @@
           <a:lstStyle/>
           <a:p>
             <a:pPr algn="ctr"/>
+            <a:endParaRPr/>
           </a:p>
         </p:txBody>
       </p:sp>
@@ -7988,7 +8278,7 @@
           <a:noFill/>
         </p:spPr>
         <p:txBody>
-          <a:bodyPr wrap="square" anchor="t" lIns="0" rIns="0" tIns="0" bIns="0">
+          <a:bodyPr wrap="square" lIns="0" tIns="0" rIns="0" bIns="0" anchor="t">
             <a:spAutoFit/>
           </a:bodyPr>
           <a:lstStyle/>
@@ -8023,7 +8313,7 @@
           <a:noFill/>
         </p:spPr>
         <p:txBody>
-          <a:bodyPr wrap="square" anchor="ctr" lIns="0" rIns="0" tIns="0" bIns="0">
+          <a:bodyPr wrap="square" lIns="0" tIns="0" rIns="0" bIns="0" anchor="ctr">
             <a:spAutoFit/>
           </a:bodyPr>
           <a:lstStyle/>
@@ -8058,7 +8348,7 @@
           <a:noFill/>
         </p:spPr>
         <p:txBody>
-          <a:bodyPr wrap="square" anchor="ctr" lIns="0" rIns="0" tIns="0" bIns="0">
+          <a:bodyPr wrap="square" lIns="0" tIns="0" rIns="0" bIns="0" anchor="ctr">
             <a:spAutoFit/>
           </a:bodyPr>
           <a:lstStyle/>
@@ -8117,6 +8407,7 @@
           <a:lstStyle/>
           <a:p>
             <a:pPr algn="ctr"/>
+            <a:endParaRPr/>
           </a:p>
         </p:txBody>
       </p:sp>
@@ -8137,7 +8428,7 @@
           <a:noFill/>
         </p:spPr>
         <p:txBody>
-          <a:bodyPr wrap="square" anchor="ctr" lIns="0" rIns="0" tIns="0" bIns="0">
+          <a:bodyPr wrap="square" lIns="0" tIns="0" rIns="0" bIns="0" anchor="ctr">
             <a:spAutoFit/>
           </a:bodyPr>
           <a:lstStyle/>
@@ -8172,7 +8463,7 @@
           <a:noFill/>
         </p:spPr>
         <p:txBody>
-          <a:bodyPr wrap="square" anchor="ctr" lIns="0" rIns="0" tIns="0" bIns="0">
+          <a:bodyPr wrap="square" lIns="0" tIns="0" rIns="0" bIns="0" anchor="ctr">
             <a:spAutoFit/>
           </a:bodyPr>
           <a:lstStyle/>
@@ -8233,6 +8524,7 @@
           <a:lstStyle/>
           <a:p>
             <a:pPr algn="ctr"/>
+            <a:endParaRPr/>
           </a:p>
         </p:txBody>
       </p:sp>
@@ -8253,7 +8545,7 @@
           <a:noFill/>
         </p:spPr>
         <p:txBody>
-          <a:bodyPr wrap="square" anchor="ctr" lIns="0" rIns="0" tIns="0" bIns="0">
+          <a:bodyPr wrap="square" lIns="0" tIns="0" rIns="0" bIns="0" anchor="ctr">
             <a:spAutoFit/>
           </a:bodyPr>
           <a:lstStyle/>
@@ -8288,7 +8580,7 @@
           <a:noFill/>
         </p:spPr>
         <p:txBody>
-          <a:bodyPr wrap="square" anchor="t" lIns="0" rIns="0" tIns="0" bIns="0">
+          <a:bodyPr wrap="square" lIns="0" tIns="0" rIns="0" bIns="0" anchor="t">
             <a:spAutoFit/>
           </a:bodyPr>
           <a:lstStyle/>
@@ -8349,6 +8641,7 @@
           <a:lstStyle/>
           <a:p>
             <a:pPr algn="ctr"/>
+            <a:endParaRPr/>
           </a:p>
         </p:txBody>
       </p:sp>
@@ -8369,7 +8662,7 @@
           <a:noFill/>
         </p:spPr>
         <p:txBody>
-          <a:bodyPr wrap="square" anchor="ctr" lIns="0" rIns="0" tIns="0" bIns="0">
+          <a:bodyPr wrap="square" lIns="0" tIns="0" rIns="0" bIns="0" anchor="ctr">
             <a:spAutoFit/>
           </a:bodyPr>
           <a:lstStyle/>
@@ -8404,7 +8697,7 @@
           <a:noFill/>
         </p:spPr>
         <p:txBody>
-          <a:bodyPr wrap="square" anchor="t" lIns="0" rIns="0" tIns="0" bIns="0">
+          <a:bodyPr wrap="square" lIns="0" tIns="0" rIns="0" bIns="0" anchor="t">
             <a:spAutoFit/>
           </a:bodyPr>
           <a:lstStyle/>
@@ -8465,6 +8758,7 @@
           <a:lstStyle/>
           <a:p>
             <a:pPr algn="ctr"/>
+            <a:endParaRPr/>
           </a:p>
         </p:txBody>
       </p:sp>
@@ -8509,6 +8803,7 @@
           <a:lstStyle/>
           <a:p>
             <a:pPr algn="ctr"/>
+            <a:endParaRPr/>
           </a:p>
         </p:txBody>
       </p:sp>
@@ -8529,7 +8824,7 @@
           <a:noFill/>
         </p:spPr>
         <p:txBody>
-          <a:bodyPr wrap="square" anchor="t" lIns="0" rIns="0" tIns="0" bIns="0">
+          <a:bodyPr wrap="square" lIns="0" tIns="0" rIns="0" bIns="0" anchor="t">
             <a:spAutoFit/>
           </a:bodyPr>
           <a:lstStyle/>
@@ -8564,7 +8859,7 @@
           <a:noFill/>
         </p:spPr>
         <p:txBody>
-          <a:bodyPr wrap="square" anchor="t" lIns="0" rIns="0" tIns="0" bIns="0">
+          <a:bodyPr wrap="square" lIns="0" tIns="0" rIns="0" bIns="0" anchor="t">
             <a:spAutoFit/>
           </a:bodyPr>
           <a:lstStyle/>
@@ -8757,7 +9052,7 @@
           <a:noFill/>
         </p:spPr>
         <p:txBody>
-          <a:bodyPr wrap="square" anchor="t" lIns="0" rIns="0" tIns="0" bIns="0">
+          <a:bodyPr wrap="square" lIns="0" tIns="0" rIns="0" bIns="0" anchor="t">
             <a:spAutoFit/>
           </a:bodyPr>
           <a:lstStyle/>
@@ -8860,6 +9155,7 @@
           <a:lstStyle/>
           <a:p>
             <a:pPr algn="ctr"/>
+            <a:endParaRPr/>
           </a:p>
         </p:txBody>
       </p:sp>
@@ -8904,7 +9200,7 @@
           <a:noFill/>
         </p:spPr>
         <p:txBody>
-          <a:bodyPr wrap="square" anchor="t" lIns="0" rIns="0" tIns="0" bIns="0">
+          <a:bodyPr wrap="square" lIns="0" tIns="0" rIns="0" bIns="0" anchor="t">
             <a:spAutoFit/>
           </a:bodyPr>
           <a:lstStyle/>
@@ -8931,7 +9227,7 @@
 </file>
 
 <file path=ppt/slides/slide6.xml><?xml version="1.0" encoding="utf-8"?>
-<p:sld xmlns:a="http://schemas.openxmlformats.org/drawingml/2006/main" xmlns:p="http://schemas.openxmlformats.org/presentationml/2006/main" xmlns:r="http://schemas.openxmlformats.org/officeDocument/2006/relationships">
+<p:sld xmlns:a="http://schemas.openxmlformats.org/drawingml/2006/main" xmlns:r="http://schemas.openxmlformats.org/officeDocument/2006/relationships" xmlns:p="http://schemas.openxmlformats.org/presentationml/2006/main">
   <p:cSld>
     <p:spTree>
       <p:nvGrpSpPr>
@@ -8939,7 +9235,14 @@
         <p:cNvGrpSpPr/>
         <p:nvPr/>
       </p:nvGrpSpPr>
-      <p:grpSpPr/>
+      <p:grpSpPr>
+        <a:xfrm>
+          <a:off x="0" y="0"/>
+          <a:ext cx="0" cy="0"/>
+          <a:chOff x="0" y="0"/>
+          <a:chExt cx="0" cy="0"/>
+        </a:xfrm>
+      </p:grpSpPr>
       <p:sp>
         <p:nvSpPr>
           <p:cNvPr id="2" name="Rectangle 1"/>
@@ -8981,6 +9284,7 @@
           <a:lstStyle/>
           <a:p>
             <a:pPr algn="ctr"/>
+            <a:endParaRPr/>
           </a:p>
         </p:txBody>
       </p:sp>
@@ -9025,6 +9329,7 @@
           <a:lstStyle/>
           <a:p>
             <a:pPr algn="ctr"/>
+            <a:endParaRPr/>
           </a:p>
         </p:txBody>
       </p:sp>
@@ -9069,6 +9374,7 @@
           <a:lstStyle/>
           <a:p>
             <a:pPr algn="ctr"/>
+            <a:endParaRPr/>
           </a:p>
         </p:txBody>
       </p:sp>
@@ -9089,7 +9395,7 @@
           <a:noFill/>
         </p:spPr>
         <p:txBody>
-          <a:bodyPr wrap="square" anchor="t" lIns="0" rIns="0" tIns="0" bIns="0">
+          <a:bodyPr wrap="square" lIns="0" tIns="0" rIns="0" bIns="0" anchor="t">
             <a:spAutoFit/>
           </a:bodyPr>
           <a:lstStyle/>
@@ -9124,7 +9430,7 @@
           <a:noFill/>
         </p:spPr>
         <p:txBody>
-          <a:bodyPr wrap="square" anchor="ctr" lIns="0" rIns="0" tIns="0" bIns="0">
+          <a:bodyPr wrap="square" lIns="0" tIns="0" rIns="0" bIns="0" anchor="ctr">
             <a:spAutoFit/>
           </a:bodyPr>
           <a:lstStyle/>
@@ -9159,7 +9465,7 @@
           <a:noFill/>
         </p:spPr>
         <p:txBody>
-          <a:bodyPr wrap="square" anchor="ctr" lIns="0" rIns="0" tIns="0" bIns="0">
+          <a:bodyPr wrap="square" lIns="0" tIns="0" rIns="0" bIns="0" anchor="ctr">
             <a:spAutoFit/>
           </a:bodyPr>
           <a:lstStyle/>
@@ -9218,6 +9524,7 @@
           <a:lstStyle/>
           <a:p>
             <a:pPr algn="ctr"/>
+            <a:endParaRPr/>
           </a:p>
         </p:txBody>
       </p:sp>
@@ -9238,7 +9545,7 @@
           <a:noFill/>
         </p:spPr>
         <p:txBody>
-          <a:bodyPr wrap="square" anchor="ctr" lIns="0" rIns="0" tIns="0" bIns="0">
+          <a:bodyPr wrap="square" lIns="0" tIns="0" rIns="0" bIns="0" anchor="ctr">
             <a:spAutoFit/>
           </a:bodyPr>
           <a:lstStyle/>
@@ -9273,7 +9580,7 @@
           <a:noFill/>
         </p:spPr>
         <p:txBody>
-          <a:bodyPr wrap="square" anchor="ctr" lIns="0" rIns="0" tIns="0" bIns="0">
+          <a:bodyPr wrap="square" lIns="0" tIns="0" rIns="0" bIns="0" anchor="ctr">
             <a:spAutoFit/>
           </a:bodyPr>
           <a:lstStyle/>
@@ -9334,6 +9641,7 @@
           <a:lstStyle/>
           <a:p>
             <a:pPr algn="ctr"/>
+            <a:endParaRPr/>
           </a:p>
         </p:txBody>
       </p:sp>
@@ -9354,7 +9662,7 @@
           <a:noFill/>
         </p:spPr>
         <p:txBody>
-          <a:bodyPr wrap="square" anchor="ctr" lIns="0" rIns="0" tIns="0" bIns="0">
+          <a:bodyPr wrap="square" lIns="0" tIns="0" rIns="0" bIns="0" anchor="ctr">
             <a:spAutoFit/>
           </a:bodyPr>
           <a:lstStyle/>
@@ -9389,7 +9697,7 @@
           <a:noFill/>
         </p:spPr>
         <p:txBody>
-          <a:bodyPr wrap="square" anchor="t" lIns="0" rIns="0" tIns="0" bIns="0">
+          <a:bodyPr wrap="square" lIns="0" tIns="0" rIns="0" bIns="0" anchor="t">
             <a:spAutoFit/>
           </a:bodyPr>
           <a:lstStyle/>
@@ -9450,6 +9758,7 @@
           <a:lstStyle/>
           <a:p>
             <a:pPr algn="ctr"/>
+            <a:endParaRPr/>
           </a:p>
         </p:txBody>
       </p:sp>
@@ -9470,7 +9779,7 @@
           <a:noFill/>
         </p:spPr>
         <p:txBody>
-          <a:bodyPr wrap="square" anchor="ctr" lIns="0" rIns="0" tIns="0" bIns="0">
+          <a:bodyPr wrap="square" lIns="0" tIns="0" rIns="0" bIns="0" anchor="ctr">
             <a:spAutoFit/>
           </a:bodyPr>
           <a:lstStyle/>
@@ -9505,7 +9814,7 @@
           <a:noFill/>
         </p:spPr>
         <p:txBody>
-          <a:bodyPr wrap="square" anchor="t" lIns="0" rIns="0" tIns="0" bIns="0">
+          <a:bodyPr wrap="square" lIns="0" tIns="0" rIns="0" bIns="0" anchor="t">
             <a:spAutoFit/>
           </a:bodyPr>
           <a:lstStyle/>
@@ -9566,6 +9875,7 @@
           <a:lstStyle/>
           <a:p>
             <a:pPr algn="ctr"/>
+            <a:endParaRPr/>
           </a:p>
         </p:txBody>
       </p:sp>
@@ -9610,6 +9920,7 @@
           <a:lstStyle/>
           <a:p>
             <a:pPr algn="ctr"/>
+            <a:endParaRPr/>
           </a:p>
         </p:txBody>
       </p:sp>
@@ -9630,7 +9941,7 @@
           <a:noFill/>
         </p:spPr>
         <p:txBody>
-          <a:bodyPr wrap="square" anchor="t" lIns="0" rIns="0" tIns="0" bIns="0">
+          <a:bodyPr wrap="square" lIns="0" tIns="0" rIns="0" bIns="0" anchor="t">
             <a:spAutoFit/>
           </a:bodyPr>
           <a:lstStyle/>
@@ -9665,7 +9976,7 @@
           <a:noFill/>
         </p:spPr>
         <p:txBody>
-          <a:bodyPr wrap="square" anchor="t" lIns="0" rIns="0" tIns="0" bIns="0">
+          <a:bodyPr wrap="square" lIns="0" tIns="0" rIns="0" bIns="0" anchor="t">
             <a:spAutoFit/>
           </a:bodyPr>
           <a:lstStyle/>
@@ -9824,6 +10135,7 @@
           <a:lstStyle/>
           <a:p>
             <a:pPr algn="ctr"/>
+            <a:endParaRPr/>
           </a:p>
         </p:txBody>
       </p:sp>
@@ -9892,6 +10204,7 @@
           <a:lstStyle/>
           <a:p>
             <a:pPr algn="ctr"/>
+            <a:endParaRPr/>
           </a:p>
         </p:txBody>
       </p:sp>
@@ -9936,7 +10249,7 @@
           <a:noFill/>
         </p:spPr>
         <p:txBody>
-          <a:bodyPr wrap="square" anchor="t" lIns="0" rIns="0" tIns="0" bIns="0">
+          <a:bodyPr wrap="square" lIns="0" tIns="0" rIns="0" bIns="0" anchor="t">
             <a:spAutoFit/>
           </a:bodyPr>
           <a:lstStyle/>
@@ -9963,7 +10276,7 @@
 </file>
 
 <file path=ppt/slides/slide7.xml><?xml version="1.0" encoding="utf-8"?>
-<p:sld xmlns:a="http://schemas.openxmlformats.org/drawingml/2006/main" xmlns:p="http://schemas.openxmlformats.org/presentationml/2006/main" xmlns:r="http://schemas.openxmlformats.org/officeDocument/2006/relationships">
+<p:sld xmlns:a="http://schemas.openxmlformats.org/drawingml/2006/main" xmlns:r="http://schemas.openxmlformats.org/officeDocument/2006/relationships" xmlns:p="http://schemas.openxmlformats.org/presentationml/2006/main">
   <p:cSld>
     <p:spTree>
       <p:nvGrpSpPr>
@@ -9971,7 +10284,14 @@
         <p:cNvGrpSpPr/>
         <p:nvPr/>
       </p:nvGrpSpPr>
-      <p:grpSpPr/>
+      <p:grpSpPr>
+        <a:xfrm>
+          <a:off x="0" y="0"/>
+          <a:ext cx="0" cy="0"/>
+          <a:chOff x="0" y="0"/>
+          <a:chExt cx="0" cy="0"/>
+        </a:xfrm>
+      </p:grpSpPr>
       <p:sp>
         <p:nvSpPr>
           <p:cNvPr id="2" name="Rectangle 1"/>
@@ -10013,6 +10333,7 @@
           <a:lstStyle/>
           <a:p>
             <a:pPr algn="ctr"/>
+            <a:endParaRPr/>
           </a:p>
         </p:txBody>
       </p:sp>
@@ -10057,6 +10378,7 @@
           <a:lstStyle/>
           <a:p>
             <a:pPr algn="ctr"/>
+            <a:endParaRPr/>
           </a:p>
         </p:txBody>
       </p:sp>
@@ -10101,6 +10423,7 @@
           <a:lstStyle/>
           <a:p>
             <a:pPr algn="ctr"/>
+            <a:endParaRPr/>
           </a:p>
         </p:txBody>
       </p:sp>
@@ -10121,7 +10444,7 @@
           <a:noFill/>
         </p:spPr>
         <p:txBody>
-          <a:bodyPr wrap="square" anchor="t" lIns="0" rIns="0" tIns="0" bIns="0">
+          <a:bodyPr wrap="square" lIns="0" tIns="0" rIns="0" bIns="0" anchor="t">
             <a:spAutoFit/>
           </a:bodyPr>
           <a:lstStyle/>
@@ -10156,7 +10479,7 @@
           <a:noFill/>
         </p:spPr>
         <p:txBody>
-          <a:bodyPr wrap="square" anchor="ctr" lIns="0" rIns="0" tIns="0" bIns="0">
+          <a:bodyPr wrap="square" lIns="0" tIns="0" rIns="0" bIns="0" anchor="ctr">
             <a:spAutoFit/>
           </a:bodyPr>
           <a:lstStyle/>
@@ -10191,7 +10514,7 @@
           <a:noFill/>
         </p:spPr>
         <p:txBody>
-          <a:bodyPr wrap="square" anchor="ctr" lIns="0" rIns="0" tIns="0" bIns="0">
+          <a:bodyPr wrap="square" lIns="0" tIns="0" rIns="0" bIns="0" anchor="ctr">
             <a:spAutoFit/>
           </a:bodyPr>
           <a:lstStyle/>
@@ -10250,6 +10573,7 @@
           <a:lstStyle/>
           <a:p>
             <a:pPr algn="ctr"/>
+            <a:endParaRPr/>
           </a:p>
         </p:txBody>
       </p:sp>
@@ -10270,7 +10594,7 @@
           <a:noFill/>
         </p:spPr>
         <p:txBody>
-          <a:bodyPr wrap="square" anchor="ctr" lIns="0" rIns="0" tIns="0" bIns="0">
+          <a:bodyPr wrap="square" lIns="0" tIns="0" rIns="0" bIns="0" anchor="ctr">
             <a:spAutoFit/>
           </a:bodyPr>
           <a:lstStyle/>
@@ -10305,7 +10629,7 @@
           <a:noFill/>
         </p:spPr>
         <p:txBody>
-          <a:bodyPr wrap="square" anchor="ctr" lIns="0" rIns="0" tIns="0" bIns="0">
+          <a:bodyPr wrap="square" lIns="0" tIns="0" rIns="0" bIns="0" anchor="ctr">
             <a:spAutoFit/>
           </a:bodyPr>
           <a:lstStyle/>
@@ -10366,6 +10690,7 @@
           <a:lstStyle/>
           <a:p>
             <a:pPr algn="ctr"/>
+            <a:endParaRPr/>
           </a:p>
         </p:txBody>
       </p:sp>
@@ -10410,6 +10735,7 @@
           <a:lstStyle/>
           <a:p>
             <a:pPr algn="ctr"/>
+            <a:endParaRPr/>
           </a:p>
         </p:txBody>
       </p:sp>
@@ -10430,7 +10756,7 @@
           <a:noFill/>
         </p:spPr>
         <p:txBody>
-          <a:bodyPr wrap="square" anchor="t" lIns="0" rIns="0" tIns="0" bIns="0">
+          <a:bodyPr wrap="square" lIns="0" tIns="0" rIns="0" bIns="0" anchor="t">
             <a:spAutoFit/>
           </a:bodyPr>
           <a:lstStyle/>
@@ -10465,7 +10791,7 @@
           <a:noFill/>
         </p:spPr>
         <p:txBody>
-          <a:bodyPr wrap="square" anchor="t" lIns="0" rIns="0" tIns="0" bIns="0">
+          <a:bodyPr wrap="square" lIns="0" tIns="0" rIns="0" bIns="0" anchor="t">
             <a:spAutoFit/>
           </a:bodyPr>
           <a:lstStyle/>
@@ -10528,6 +10854,7 @@
           <a:lstStyle/>
           <a:p>
             <a:pPr algn="ctr"/>
+            <a:endParaRPr/>
           </a:p>
         </p:txBody>
       </p:sp>
@@ -10548,7 +10875,7 @@
           <a:noFill/>
         </p:spPr>
         <p:txBody>
-          <a:bodyPr wrap="square" anchor="ctr" lIns="0" rIns="0" tIns="0" bIns="0">
+          <a:bodyPr wrap="square" lIns="0" tIns="0" rIns="0" bIns="0" anchor="ctr">
             <a:spAutoFit/>
           </a:bodyPr>
           <a:lstStyle/>
@@ -10583,7 +10910,7 @@
           <a:noFill/>
         </p:spPr>
         <p:txBody>
-          <a:bodyPr wrap="square" anchor="ctr" lIns="0" rIns="0" tIns="0" bIns="0">
+          <a:bodyPr wrap="square" lIns="0" tIns="0" rIns="0" bIns="0" anchor="ctr">
             <a:spAutoFit/>
           </a:bodyPr>
           <a:lstStyle/>
@@ -10646,6 +10973,7 @@
           <a:lstStyle/>
           <a:p>
             <a:pPr algn="ctr"/>
+            <a:endParaRPr/>
           </a:p>
         </p:txBody>
       </p:sp>
@@ -10666,7 +10994,7 @@
           <a:noFill/>
         </p:spPr>
         <p:txBody>
-          <a:bodyPr wrap="square" anchor="ctr" lIns="0" rIns="0" tIns="0" bIns="0">
+          <a:bodyPr wrap="square" lIns="0" tIns="0" rIns="0" bIns="0" anchor="ctr">
             <a:spAutoFit/>
           </a:bodyPr>
           <a:lstStyle/>
@@ -10701,7 +11029,7 @@
           <a:noFill/>
         </p:spPr>
         <p:txBody>
-          <a:bodyPr wrap="square" anchor="ctr" lIns="0" rIns="0" tIns="0" bIns="0">
+          <a:bodyPr wrap="square" lIns="0" tIns="0" rIns="0" bIns="0" anchor="ctr">
             <a:spAutoFit/>
           </a:bodyPr>
           <a:lstStyle/>
@@ -10764,6 +11092,7 @@
           <a:lstStyle/>
           <a:p>
             <a:pPr algn="ctr"/>
+            <a:endParaRPr/>
           </a:p>
         </p:txBody>
       </p:sp>
@@ -10784,7 +11113,7 @@
           <a:noFill/>
         </p:spPr>
         <p:txBody>
-          <a:bodyPr wrap="square" anchor="ctr" lIns="0" rIns="0" tIns="0" bIns="0">
+          <a:bodyPr wrap="square" lIns="0" tIns="0" rIns="0" bIns="0" anchor="ctr">
             <a:spAutoFit/>
           </a:bodyPr>
           <a:lstStyle/>
@@ -10819,7 +11148,7 @@
           <a:noFill/>
         </p:spPr>
         <p:txBody>
-          <a:bodyPr wrap="square" anchor="ctr" lIns="0" rIns="0" tIns="0" bIns="0">
+          <a:bodyPr wrap="square" lIns="0" tIns="0" rIns="0" bIns="0" anchor="ctr">
             <a:spAutoFit/>
           </a:bodyPr>
           <a:lstStyle/>
@@ -10882,6 +11211,7 @@
           <a:lstStyle/>
           <a:p>
             <a:pPr algn="ctr"/>
+            <a:endParaRPr/>
           </a:p>
         </p:txBody>
       </p:sp>
@@ -10902,7 +11232,7 @@
           <a:noFill/>
         </p:spPr>
         <p:txBody>
-          <a:bodyPr wrap="square" anchor="ctr" lIns="0" rIns="0" tIns="0" bIns="0">
+          <a:bodyPr wrap="square" lIns="0" tIns="0" rIns="0" bIns="0" anchor="ctr">
             <a:spAutoFit/>
           </a:bodyPr>
           <a:lstStyle/>
@@ -10937,7 +11267,7 @@
           <a:noFill/>
         </p:spPr>
         <p:txBody>
-          <a:bodyPr wrap="square" anchor="ctr" lIns="0" rIns="0" tIns="0" bIns="0">
+          <a:bodyPr wrap="square" lIns="0" tIns="0" rIns="0" bIns="0" anchor="ctr">
             <a:spAutoFit/>
           </a:bodyPr>
           <a:lstStyle/>
@@ -11000,6 +11330,7 @@
           <a:lstStyle/>
           <a:p>
             <a:pPr algn="ctr"/>
+            <a:endParaRPr/>
           </a:p>
         </p:txBody>
       </p:sp>
@@ -11020,7 +11351,7 @@
           <a:noFill/>
         </p:spPr>
         <p:txBody>
-          <a:bodyPr wrap="square" anchor="ctr" lIns="0" rIns="0" tIns="0" bIns="0">
+          <a:bodyPr wrap="square" lIns="0" tIns="0" rIns="0" bIns="0" anchor="ctr">
             <a:spAutoFit/>
           </a:bodyPr>
           <a:lstStyle/>
@@ -11055,7 +11386,7 @@
           <a:noFill/>
         </p:spPr>
         <p:txBody>
-          <a:bodyPr wrap="square" anchor="ctr" lIns="0" rIns="0" tIns="0" bIns="0">
+          <a:bodyPr wrap="square" lIns="0" tIns="0" rIns="0" bIns="0" anchor="ctr">
             <a:spAutoFit/>
           </a:bodyPr>
           <a:lstStyle/>
@@ -11118,6 +11449,7 @@
           <a:lstStyle/>
           <a:p>
             <a:pPr algn="ctr"/>
+            <a:endParaRPr/>
           </a:p>
         </p:txBody>
       </p:sp>
@@ -11138,7 +11470,7 @@
           <a:noFill/>
         </p:spPr>
         <p:txBody>
-          <a:bodyPr wrap="square" anchor="ctr" lIns="0" rIns="0" tIns="0" bIns="0">
+          <a:bodyPr wrap="square" lIns="0" tIns="0" rIns="0" bIns="0" anchor="ctr">
             <a:spAutoFit/>
           </a:bodyPr>
           <a:lstStyle/>
@@ -11173,7 +11505,7 @@
           <a:noFill/>
         </p:spPr>
         <p:txBody>
-          <a:bodyPr wrap="square" anchor="ctr" lIns="0" rIns="0" tIns="0" bIns="0">
+          <a:bodyPr wrap="square" lIns="0" tIns="0" rIns="0" bIns="0" anchor="ctr">
             <a:spAutoFit/>
           </a:bodyPr>
           <a:lstStyle/>
@@ -11236,6 +11568,7 @@
           <a:lstStyle/>
           <a:p>
             <a:pPr algn="ctr"/>
+            <a:endParaRPr/>
           </a:p>
         </p:txBody>
       </p:sp>
@@ -11256,7 +11589,7 @@
           <a:noFill/>
         </p:spPr>
         <p:txBody>
-          <a:bodyPr wrap="square" anchor="ctr" lIns="0" rIns="0" tIns="0" bIns="0">
+          <a:bodyPr wrap="square" lIns="0" tIns="0" rIns="0" bIns="0" anchor="ctr">
             <a:spAutoFit/>
           </a:bodyPr>
           <a:lstStyle/>
@@ -11319,6 +11652,7 @@
           <a:lstStyle/>
           <a:p>
             <a:pPr algn="ctr"/>
+            <a:endParaRPr/>
           </a:p>
         </p:txBody>
       </p:sp>
@@ -11339,7 +11673,7 @@
           <a:noFill/>
         </p:spPr>
         <p:txBody>
-          <a:bodyPr wrap="square" anchor="ctr" lIns="0" rIns="0" tIns="0" bIns="0">
+          <a:bodyPr wrap="square" lIns="0" tIns="0" rIns="0" bIns="0" anchor="ctr">
             <a:spAutoFit/>
           </a:bodyPr>
           <a:lstStyle/>
@@ -11374,7 +11708,7 @@
           <a:noFill/>
         </p:spPr>
         <p:txBody>
-          <a:bodyPr wrap="square" anchor="ctr" lIns="0" rIns="0" tIns="0" bIns="0">
+          <a:bodyPr wrap="square" lIns="0" tIns="0" rIns="0" bIns="0" anchor="ctr">
             <a:spAutoFit/>
           </a:bodyPr>
           <a:lstStyle/>
@@ -11437,6 +11771,7 @@
           <a:lstStyle/>
           <a:p>
             <a:pPr algn="ctr"/>
+            <a:endParaRPr/>
           </a:p>
         </p:txBody>
       </p:sp>
@@ -11457,7 +11792,7 @@
           <a:noFill/>
         </p:spPr>
         <p:txBody>
-          <a:bodyPr wrap="square" anchor="ctr" lIns="0" rIns="0" tIns="0" bIns="0">
+          <a:bodyPr wrap="square" lIns="0" tIns="0" rIns="0" bIns="0" anchor="ctr">
             <a:spAutoFit/>
           </a:bodyPr>
           <a:lstStyle/>
@@ -11520,6 +11855,7 @@
           <a:lstStyle/>
           <a:p>
             <a:pPr algn="ctr"/>
+            <a:endParaRPr/>
           </a:p>
         </p:txBody>
       </p:sp>
@@ -11540,7 +11876,7 @@
           <a:noFill/>
         </p:spPr>
         <p:txBody>
-          <a:bodyPr wrap="square" anchor="ctr" lIns="0" rIns="0" tIns="0" bIns="0">
+          <a:bodyPr wrap="square" lIns="0" tIns="0" rIns="0" bIns="0" anchor="ctr">
             <a:spAutoFit/>
           </a:bodyPr>
           <a:lstStyle/>
@@ -11603,6 +11939,7 @@
           <a:lstStyle/>
           <a:p>
             <a:pPr algn="ctr"/>
+            <a:endParaRPr/>
           </a:p>
         </p:txBody>
       </p:sp>
@@ -11623,7 +11960,7 @@
           <a:noFill/>
         </p:spPr>
         <p:txBody>
-          <a:bodyPr wrap="square" anchor="ctr" lIns="0" rIns="0" tIns="0" bIns="0">
+          <a:bodyPr wrap="square" lIns="0" tIns="0" rIns="0" bIns="0" anchor="ctr">
             <a:spAutoFit/>
           </a:bodyPr>
           <a:lstStyle/>
@@ -11658,7 +11995,7 @@
           <a:noFill/>
         </p:spPr>
         <p:txBody>
-          <a:bodyPr wrap="square" anchor="t" lIns="0" rIns="0" tIns="0" bIns="0">
+          <a:bodyPr wrap="square" lIns="0" tIns="0" rIns="0" bIns="0" anchor="t">
             <a:spAutoFit/>
           </a:bodyPr>
           <a:lstStyle/>
@@ -11721,6 +12058,7 @@
           <a:lstStyle/>
           <a:p>
             <a:pPr algn="ctr"/>
+            <a:endParaRPr/>
           </a:p>
         </p:txBody>
       </p:sp>
@@ -11741,7 +12079,7 @@
           <a:noFill/>
         </p:spPr>
         <p:txBody>
-          <a:bodyPr wrap="square" anchor="ctr" lIns="0" rIns="0" tIns="0" bIns="0">
+          <a:bodyPr wrap="square" lIns="0" tIns="0" rIns="0" bIns="0" anchor="ctr">
             <a:spAutoFit/>
           </a:bodyPr>
           <a:lstStyle/>
@@ -11776,7 +12114,7 @@
           <a:noFill/>
         </p:spPr>
         <p:txBody>
-          <a:bodyPr wrap="square" anchor="ctr" lIns="0" rIns="0" tIns="0" bIns="0">
+          <a:bodyPr wrap="square" lIns="0" tIns="0" rIns="0" bIns="0" anchor="ctr">
             <a:spAutoFit/>
           </a:bodyPr>
           <a:lstStyle/>
@@ -11835,6 +12173,7 @@
           <a:lstStyle/>
           <a:p>
             <a:pPr algn="ctr"/>
+            <a:endParaRPr/>
           </a:p>
         </p:txBody>
       </p:sp>
@@ -11855,7 +12194,7 @@
           <a:noFill/>
         </p:spPr>
         <p:txBody>
-          <a:bodyPr wrap="square" anchor="ctr" lIns="0" rIns="0" tIns="0" bIns="0">
+          <a:bodyPr wrap="square" lIns="0" tIns="0" rIns="0" bIns="0" anchor="ctr">
             <a:spAutoFit/>
           </a:bodyPr>
           <a:lstStyle/>
@@ -11890,7 +12229,7 @@
           <a:noFill/>
         </p:spPr>
         <p:txBody>
-          <a:bodyPr wrap="square" anchor="t" lIns="0" rIns="0" tIns="0" bIns="0">
+          <a:bodyPr wrap="square" lIns="0" tIns="0" rIns="0" bIns="0" anchor="t">
             <a:spAutoFit/>
           </a:bodyPr>
           <a:lstStyle/>
@@ -11949,6 +12288,7 @@
           <a:lstStyle/>
           <a:p>
             <a:pPr algn="ctr"/>
+            <a:endParaRPr/>
           </a:p>
         </p:txBody>
       </p:sp>
@@ -11969,7 +12309,7 @@
           <a:noFill/>
         </p:spPr>
         <p:txBody>
-          <a:bodyPr wrap="square" anchor="ctr" lIns="0" rIns="0" tIns="0" bIns="0">
+          <a:bodyPr wrap="square" lIns="0" tIns="0" rIns="0" bIns="0" anchor="ctr">
             <a:spAutoFit/>
           </a:bodyPr>
           <a:lstStyle/>
@@ -12004,7 +12344,7 @@
           <a:noFill/>
         </p:spPr>
         <p:txBody>
-          <a:bodyPr wrap="square" anchor="ctr" lIns="0" rIns="0" tIns="0" bIns="0">
+          <a:bodyPr wrap="square" lIns="0" tIns="0" rIns="0" bIns="0" anchor="ctr">
             <a:spAutoFit/>
           </a:bodyPr>
           <a:lstStyle/>
@@ -12039,7 +12379,7 @@
           <a:noFill/>
         </p:spPr>
         <p:txBody>
-          <a:bodyPr wrap="square" anchor="t" lIns="0" rIns="0" tIns="0" bIns="0">
+          <a:bodyPr wrap="square" lIns="0" tIns="0" rIns="0" bIns="0" anchor="t">
             <a:spAutoFit/>
           </a:bodyPr>
           <a:lstStyle/>
@@ -12109,6 +12449,7 @@
           <a:lstStyle/>
           <a:p>
             <a:pPr algn="ctr"/>
+            <a:endParaRPr/>
           </a:p>
         </p:txBody>
       </p:sp>
@@ -12129,7 +12470,7 @@
           <a:noFill/>
         </p:spPr>
         <p:txBody>
-          <a:bodyPr wrap="square" anchor="t" lIns="0" rIns="0" tIns="0" bIns="0">
+          <a:bodyPr wrap="square" lIns="0" tIns="0" rIns="0" bIns="0" anchor="t">
             <a:spAutoFit/>
           </a:bodyPr>
           <a:lstStyle/>
@@ -12164,7 +12505,7 @@
           <a:noFill/>
         </p:spPr>
         <p:txBody>
-          <a:bodyPr wrap="square" anchor="ctr" lIns="0" rIns="0" tIns="0" bIns="0">
+          <a:bodyPr wrap="square" lIns="0" tIns="0" rIns="0" bIns="0" anchor="ctr">
             <a:spAutoFit/>
           </a:bodyPr>
           <a:lstStyle/>
@@ -12232,6 +12573,7 @@
           <a:lstStyle/>
           <a:p>
             <a:pPr algn="ctr"/>
+            <a:endParaRPr/>
           </a:p>
         </p:txBody>
       </p:sp>
@@ -12276,6 +12618,7 @@
           <a:lstStyle/>
           <a:p>
             <a:pPr algn="ctr"/>
+            <a:endParaRPr/>
           </a:p>
         </p:txBody>
       </p:sp>
@@ -12320,6 +12663,7 @@
           <a:lstStyle/>
           <a:p>
             <a:pPr algn="ctr"/>
+            <a:endParaRPr/>
           </a:p>
         </p:txBody>
       </p:sp>
@@ -12364,6 +12708,7 @@
           <a:lstStyle/>
           <a:p>
             <a:pPr algn="ctr"/>
+            <a:endParaRPr/>
           </a:p>
         </p:txBody>
       </p:sp>
@@ -12384,7 +12729,7 @@
           <a:noFill/>
         </p:spPr>
         <p:txBody>
-          <a:bodyPr wrap="square" anchor="t" lIns="0" rIns="0" tIns="0" bIns="0">
+          <a:bodyPr wrap="square" lIns="0" tIns="0" rIns="0" bIns="0" anchor="t">
             <a:spAutoFit/>
           </a:bodyPr>
           <a:lstStyle/>
@@ -12419,7 +12764,7 @@
           <a:noFill/>
         </p:spPr>
         <p:txBody>
-          <a:bodyPr wrap="square" anchor="t" lIns="0" rIns="0" tIns="0" bIns="0">
+          <a:bodyPr wrap="square" lIns="0" tIns="0" rIns="0" bIns="0" anchor="t">
             <a:spAutoFit/>
           </a:bodyPr>
           <a:lstStyle/>
@@ -12480,6 +12825,7 @@
           <a:lstStyle/>
           <a:p>
             <a:pPr algn="ctr"/>
+            <a:endParaRPr/>
           </a:p>
         </p:txBody>
       </p:sp>
@@ -12524,6 +12870,7 @@
           <a:lstStyle/>
           <a:p>
             <a:pPr algn="ctr"/>
+            <a:endParaRPr/>
           </a:p>
         </p:txBody>
       </p:sp>
@@ -12544,7 +12891,7 @@
           <a:noFill/>
         </p:spPr>
         <p:txBody>
-          <a:bodyPr wrap="square" anchor="t" lIns="0" rIns="0" tIns="0" bIns="0">
+          <a:bodyPr wrap="square" lIns="0" tIns="0" rIns="0" bIns="0" anchor="t">
             <a:spAutoFit/>
           </a:bodyPr>
           <a:lstStyle/>
@@ -12598,7 +12945,7 @@
           <a:noFill/>
         </p:spPr>
         <p:txBody>
-          <a:bodyPr wrap="square" anchor="t" lIns="0" rIns="0" tIns="0" bIns="0">
+          <a:bodyPr wrap="square" lIns="0" tIns="0" rIns="0" bIns="0" anchor="t">
             <a:spAutoFit/>
           </a:bodyPr>
           <a:lstStyle/>
@@ -12659,6 +13006,7 @@
           <a:lstStyle/>
           <a:p>
             <a:pPr algn="ctr"/>
+            <a:endParaRPr/>
           </a:p>
         </p:txBody>
       </p:sp>
@@ -12679,7 +13027,7 @@
           <a:noFill/>
         </p:spPr>
         <p:txBody>
-          <a:bodyPr wrap="square" anchor="ctr" lIns="0" rIns="0" tIns="0" bIns="0">
+          <a:bodyPr wrap="square" lIns="0" tIns="0" rIns="0" bIns="0" anchor="ctr">
             <a:spAutoFit/>
           </a:bodyPr>
           <a:lstStyle/>
@@ -12706,7 +13054,7 @@
 </file>
 
 <file path=ppt/slides/slide8.xml><?xml version="1.0" encoding="utf-8"?>
-<p:sld xmlns:a="http://schemas.openxmlformats.org/drawingml/2006/main" xmlns:p="http://schemas.openxmlformats.org/presentationml/2006/main" xmlns:r="http://schemas.openxmlformats.org/officeDocument/2006/relationships">
+<p:sld xmlns:a="http://schemas.openxmlformats.org/drawingml/2006/main" xmlns:r="http://schemas.openxmlformats.org/officeDocument/2006/relationships" xmlns:p="http://schemas.openxmlformats.org/presentationml/2006/main">
   <p:cSld>
     <p:spTree>
       <p:nvGrpSpPr>
@@ -12714,7 +13062,14 @@
         <p:cNvGrpSpPr/>
         <p:nvPr/>
       </p:nvGrpSpPr>
-      <p:grpSpPr/>
+      <p:grpSpPr>
+        <a:xfrm>
+          <a:off x="0" y="0"/>
+          <a:ext cx="0" cy="0"/>
+          <a:chOff x="0" y="0"/>
+          <a:chExt cx="0" cy="0"/>
+        </a:xfrm>
+      </p:grpSpPr>
       <p:sp>
         <p:nvSpPr>
           <p:cNvPr id="2" name="Rectangle 1"/>
@@ -12756,6 +13111,7 @@
           <a:lstStyle/>
           <a:p>
             <a:pPr algn="ctr"/>
+            <a:endParaRPr/>
           </a:p>
         </p:txBody>
       </p:sp>
@@ -12800,6 +13156,7 @@
           <a:lstStyle/>
           <a:p>
             <a:pPr algn="ctr"/>
+            <a:endParaRPr/>
           </a:p>
         </p:txBody>
       </p:sp>
@@ -12844,6 +13201,7 @@
           <a:lstStyle/>
           <a:p>
             <a:pPr algn="ctr"/>
+            <a:endParaRPr/>
           </a:p>
         </p:txBody>
       </p:sp>
@@ -12864,7 +13222,7 @@
           <a:noFill/>
         </p:spPr>
         <p:txBody>
-          <a:bodyPr wrap="square" anchor="t" lIns="0" rIns="0" tIns="0" bIns="0">
+          <a:bodyPr wrap="square" lIns="0" tIns="0" rIns="0" bIns="0" anchor="t">
             <a:spAutoFit/>
           </a:bodyPr>
           <a:lstStyle/>
@@ -12899,7 +13257,7 @@
           <a:noFill/>
         </p:spPr>
         <p:txBody>
-          <a:bodyPr wrap="square" anchor="ctr" lIns="0" rIns="0" tIns="0" bIns="0">
+          <a:bodyPr wrap="square" lIns="0" tIns="0" rIns="0" bIns="0" anchor="ctr">
             <a:spAutoFit/>
           </a:bodyPr>
           <a:lstStyle/>
@@ -12934,7 +13292,7 @@
           <a:noFill/>
         </p:spPr>
         <p:txBody>
-          <a:bodyPr wrap="square" anchor="ctr" lIns="0" rIns="0" tIns="0" bIns="0">
+          <a:bodyPr wrap="square" lIns="0" tIns="0" rIns="0" bIns="0" anchor="ctr">
             <a:spAutoFit/>
           </a:bodyPr>
           <a:lstStyle/>
@@ -12993,6 +13351,7 @@
           <a:lstStyle/>
           <a:p>
             <a:pPr algn="ctr"/>
+            <a:endParaRPr/>
           </a:p>
         </p:txBody>
       </p:sp>
@@ -13013,7 +13372,7 @@
           <a:noFill/>
         </p:spPr>
         <p:txBody>
-          <a:bodyPr wrap="square" anchor="ctr" lIns="0" rIns="0" tIns="0" bIns="0">
+          <a:bodyPr wrap="square" lIns="0" tIns="0" rIns="0" bIns="0" anchor="ctr">
             <a:spAutoFit/>
           </a:bodyPr>
           <a:lstStyle/>
@@ -13048,7 +13407,7 @@
           <a:noFill/>
         </p:spPr>
         <p:txBody>
-          <a:bodyPr wrap="square" anchor="ctr" lIns="0" rIns="0" tIns="0" bIns="0">
+          <a:bodyPr wrap="square" lIns="0" tIns="0" rIns="0" bIns="0" anchor="ctr">
             <a:spAutoFit/>
           </a:bodyPr>
           <a:lstStyle/>
@@ -13109,6 +13468,7 @@
           <a:lstStyle/>
           <a:p>
             <a:pPr algn="ctr"/>
+            <a:endParaRPr/>
           </a:p>
         </p:txBody>
       </p:sp>
@@ -13153,6 +13513,7 @@
           <a:lstStyle/>
           <a:p>
             <a:pPr algn="ctr"/>
+            <a:endParaRPr/>
           </a:p>
         </p:txBody>
       </p:sp>
@@ -13173,7 +13534,7 @@
           <a:noFill/>
         </p:spPr>
         <p:txBody>
-          <a:bodyPr wrap="square" anchor="t" lIns="0" rIns="0" tIns="0" bIns="0">
+          <a:bodyPr wrap="square" lIns="0" tIns="0" rIns="0" bIns="0" anchor="t">
             <a:spAutoFit/>
           </a:bodyPr>
           <a:lstStyle/>
@@ -13208,7 +13569,7 @@
           <a:noFill/>
         </p:spPr>
         <p:txBody>
-          <a:bodyPr wrap="square" anchor="t" lIns="0" rIns="0" tIns="0" bIns="0">
+          <a:bodyPr wrap="square" lIns="0" tIns="0" rIns="0" bIns="0" anchor="t">
             <a:spAutoFit/>
           </a:bodyPr>
           <a:lstStyle/>
@@ -13313,6 +13674,7 @@
           <a:lstStyle/>
           <a:p>
             <a:pPr algn="ctr"/>
+            <a:endParaRPr/>
           </a:p>
         </p:txBody>
       </p:sp>
@@ -13357,6 +13719,7 @@
           <a:lstStyle/>
           <a:p>
             <a:pPr algn="ctr"/>
+            <a:endParaRPr/>
           </a:p>
         </p:txBody>
       </p:sp>
@@ -13377,7 +13740,7 @@
           <a:noFill/>
         </p:spPr>
         <p:txBody>
-          <a:bodyPr wrap="square" anchor="t" lIns="0" rIns="0" tIns="0" bIns="0">
+          <a:bodyPr wrap="square" lIns="0" tIns="0" rIns="0" bIns="0" anchor="t">
             <a:spAutoFit/>
           </a:bodyPr>
           <a:lstStyle/>
@@ -13412,7 +13775,7 @@
           <a:noFill/>
         </p:spPr>
         <p:txBody>
-          <a:bodyPr wrap="square" anchor="t" lIns="0" rIns="0" tIns="0" bIns="0">
+          <a:bodyPr wrap="square" lIns="0" tIns="0" rIns="0" bIns="0" anchor="t">
             <a:spAutoFit/>
           </a:bodyPr>
           <a:lstStyle/>
@@ -13517,6 +13880,7 @@
           <a:lstStyle/>
           <a:p>
             <a:pPr algn="ctr"/>
+            <a:endParaRPr/>
           </a:p>
         </p:txBody>
       </p:sp>
@@ -13561,6 +13925,7 @@
           <a:lstStyle/>
           <a:p>
             <a:pPr algn="ctr"/>
+            <a:endParaRPr/>
           </a:p>
         </p:txBody>
       </p:sp>
@@ -13581,7 +13946,7 @@
           <a:noFill/>
         </p:spPr>
         <p:txBody>
-          <a:bodyPr wrap="square" anchor="t" lIns="0" rIns="0" tIns="0" bIns="0">
+          <a:bodyPr wrap="square" lIns="0" tIns="0" rIns="0" bIns="0" anchor="t">
             <a:spAutoFit/>
           </a:bodyPr>
           <a:lstStyle/>
@@ -13616,7 +13981,7 @@
           <a:noFill/>
         </p:spPr>
         <p:txBody>
-          <a:bodyPr wrap="square" anchor="t" lIns="0" rIns="0" tIns="0" bIns="0">
+          <a:bodyPr wrap="square" lIns="0" tIns="0" rIns="0" bIns="0" anchor="t">
             <a:spAutoFit/>
           </a:bodyPr>
           <a:lstStyle/>
@@ -13721,6 +14086,7 @@
           <a:lstStyle/>
           <a:p>
             <a:pPr algn="ctr"/>
+            <a:endParaRPr/>
           </a:p>
         </p:txBody>
       </p:sp>
@@ -13765,6 +14131,7 @@
           <a:lstStyle/>
           <a:p>
             <a:pPr algn="ctr"/>
+            <a:endParaRPr/>
           </a:p>
         </p:txBody>
       </p:sp>
@@ -13785,7 +14152,7 @@
           <a:noFill/>
         </p:spPr>
         <p:txBody>
-          <a:bodyPr wrap="square" anchor="t" lIns="0" rIns="0" tIns="0" bIns="0">
+          <a:bodyPr wrap="square" lIns="0" tIns="0" rIns="0" bIns="0" anchor="t">
             <a:spAutoFit/>
           </a:bodyPr>
           <a:lstStyle/>
@@ -13820,7 +14187,7 @@
           <a:noFill/>
         </p:spPr>
         <p:txBody>
-          <a:bodyPr wrap="square" anchor="t" lIns="0" rIns="0" tIns="0" bIns="0">
+          <a:bodyPr wrap="square" lIns="0" tIns="0" rIns="0" bIns="0" anchor="t">
             <a:spAutoFit/>
           </a:bodyPr>
           <a:lstStyle/>
@@ -13925,6 +14292,7 @@
           <a:lstStyle/>
           <a:p>
             <a:pPr algn="ctr"/>
+            <a:endParaRPr/>
           </a:p>
         </p:txBody>
       </p:sp>
@@ -13945,7 +14313,7 @@
           <a:noFill/>
         </p:spPr>
         <p:txBody>
-          <a:bodyPr wrap="square" anchor="ctr" lIns="0" rIns="0" tIns="0" bIns="0">
+          <a:bodyPr wrap="square" lIns="0" tIns="0" rIns="0" bIns="0" anchor="ctr">
             <a:spAutoFit/>
           </a:bodyPr>
           <a:lstStyle/>
@@ -13972,7 +14340,7 @@
 </file>
 
 <file path=ppt/slides/slide9.xml><?xml version="1.0" encoding="utf-8"?>
-<p:sld xmlns:a="http://schemas.openxmlformats.org/drawingml/2006/main" xmlns:p="http://schemas.openxmlformats.org/presentationml/2006/main" xmlns:r="http://schemas.openxmlformats.org/officeDocument/2006/relationships">
+<p:sld xmlns:a="http://schemas.openxmlformats.org/drawingml/2006/main" xmlns:r="http://schemas.openxmlformats.org/officeDocument/2006/relationships" xmlns:p="http://schemas.openxmlformats.org/presentationml/2006/main">
   <p:cSld>
     <p:spTree>
       <p:nvGrpSpPr>
@@ -13980,7 +14348,14 @@
         <p:cNvGrpSpPr/>
         <p:nvPr/>
       </p:nvGrpSpPr>
-      <p:grpSpPr/>
+      <p:grpSpPr>
+        <a:xfrm>
+          <a:off x="0" y="0"/>
+          <a:ext cx="0" cy="0"/>
+          <a:chOff x="0" y="0"/>
+          <a:chExt cx="0" cy="0"/>
+        </a:xfrm>
+      </p:grpSpPr>
       <p:sp>
         <p:nvSpPr>
           <p:cNvPr id="2" name="Rectangle 1"/>
@@ -14022,6 +14397,7 @@
           <a:lstStyle/>
           <a:p>
             <a:pPr algn="ctr"/>
+            <a:endParaRPr/>
           </a:p>
         </p:txBody>
       </p:sp>
@@ -14066,6 +14442,7 @@
           <a:lstStyle/>
           <a:p>
             <a:pPr algn="ctr"/>
+            <a:endParaRPr/>
           </a:p>
         </p:txBody>
       </p:sp>
@@ -14110,6 +14487,7 @@
           <a:lstStyle/>
           <a:p>
             <a:pPr algn="ctr"/>
+            <a:endParaRPr/>
           </a:p>
         </p:txBody>
       </p:sp>
@@ -14130,7 +14508,7 @@
           <a:noFill/>
         </p:spPr>
         <p:txBody>
-          <a:bodyPr wrap="square" anchor="t" lIns="0" rIns="0" tIns="0" bIns="0">
+          <a:bodyPr wrap="square" lIns="0" tIns="0" rIns="0" bIns="0" anchor="t">
             <a:spAutoFit/>
           </a:bodyPr>
           <a:lstStyle/>
@@ -14165,7 +14543,7 @@
           <a:noFill/>
         </p:spPr>
         <p:txBody>
-          <a:bodyPr wrap="square" anchor="ctr" lIns="0" rIns="0" tIns="0" bIns="0">
+          <a:bodyPr wrap="square" lIns="0" tIns="0" rIns="0" bIns="0" anchor="ctr">
             <a:spAutoFit/>
           </a:bodyPr>
           <a:lstStyle/>
@@ -14200,7 +14578,7 @@
           <a:noFill/>
         </p:spPr>
         <p:txBody>
-          <a:bodyPr wrap="square" anchor="ctr" lIns="0" rIns="0" tIns="0" bIns="0">
+          <a:bodyPr wrap="square" lIns="0" tIns="0" rIns="0" bIns="0" anchor="ctr">
             <a:spAutoFit/>
           </a:bodyPr>
           <a:lstStyle/>
@@ -14259,6 +14637,7 @@
           <a:lstStyle/>
           <a:p>
             <a:pPr algn="ctr"/>
+            <a:endParaRPr/>
           </a:p>
         </p:txBody>
       </p:sp>
@@ -14279,7 +14658,7 @@
           <a:noFill/>
         </p:spPr>
         <p:txBody>
-          <a:bodyPr wrap="square" anchor="ctr" lIns="0" rIns="0" tIns="0" bIns="0">
+          <a:bodyPr wrap="square" lIns="0" tIns="0" rIns="0" bIns="0" anchor="ctr">
             <a:spAutoFit/>
           </a:bodyPr>
           <a:lstStyle/>
@@ -14314,7 +14693,7 @@
           <a:noFill/>
         </p:spPr>
         <p:txBody>
-          <a:bodyPr wrap="square" anchor="ctr" lIns="0" rIns="0" tIns="0" bIns="0">
+          <a:bodyPr wrap="square" lIns="0" tIns="0" rIns="0" bIns="0" anchor="ctr">
             <a:spAutoFit/>
           </a:bodyPr>
           <a:lstStyle/>
@@ -14375,6 +14754,7 @@
           <a:lstStyle/>
           <a:p>
             <a:pPr algn="ctr"/>
+            <a:endParaRPr/>
           </a:p>
         </p:txBody>
       </p:sp>
@@ -14419,6 +14799,7 @@
           <a:lstStyle/>
           <a:p>
             <a:pPr algn="ctr"/>
+            <a:endParaRPr/>
           </a:p>
         </p:txBody>
       </p:sp>
@@ -14439,7 +14820,7 @@
           <a:noFill/>
         </p:spPr>
         <p:txBody>
-          <a:bodyPr wrap="square" anchor="t" lIns="0" rIns="0" tIns="0" bIns="0">
+          <a:bodyPr wrap="square" lIns="0" tIns="0" rIns="0" bIns="0" anchor="t">
             <a:spAutoFit/>
           </a:bodyPr>
           <a:lstStyle/>
@@ -14466,7 +14847,7 @@
         <p:spPr>
           <a:xfrm>
             <a:off x="868680" y="2103120"/>
-            <a:ext cx="6446520" cy="3657600"/>
+            <a:ext cx="6446520" cy="2200602"/>
           </a:xfrm>
           <a:prstGeom prst="rect">
             <a:avLst/>
@@ -14474,10 +14855,175 @@
           <a:noFill/>
         </p:spPr>
         <p:txBody>
-          <a:bodyPr wrap="square" anchor="t" lIns="0" rIns="0" tIns="0" bIns="0">
+          <a:bodyPr wrap="square" lIns="0" tIns="0" rIns="0" bIns="0" anchor="t">
             <a:spAutoFit/>
           </a:bodyPr>
           <a:lstStyle/>
+          <a:p>
+            <a:pPr>
+              <a:spcAft>
+                <a:spcPts val="900"/>
+              </a:spcAft>
+            </a:pPr>
+            <a:r>
+              <a:rPr sz="1400" b="1" i="0" dirty="0">
+                <a:solidFill>
+                  <a:srgbClr val="147D88"/>
+                </a:solidFill>
+                <a:latin typeface="Calibri"/>
+              </a:rPr>
+              <a:t>✔  </a:t>
+            </a:r>
+            <a:r>
+              <a:rPr sz="1350" b="1" i="0" dirty="0" err="1">
+                <a:solidFill>
+                  <a:srgbClr val="222B33"/>
+                </a:solidFill>
+                <a:latin typeface="Calibri"/>
+              </a:rPr>
+              <a:t>Repositorio</a:t>
+            </a:r>
+            <a:r>
+              <a:rPr sz="1350" b="1" i="0" dirty="0">
+                <a:solidFill>
+                  <a:srgbClr val="222B33"/>
+                </a:solidFill>
+                <a:latin typeface="Calibri"/>
+              </a:rPr>
+              <a:t>:  </a:t>
+            </a:r>
+            <a:r>
+              <a:rPr lang="es-CO" sz="1400" dirty="0" err="1">
+                <a:hlinkClick r:id="rId2"/>
+              </a:rPr>
+              <a:t>jgomelop</a:t>
+            </a:r>
+            <a:r>
+              <a:rPr lang="es-CO" sz="1400" dirty="0">
+                <a:hlinkClick r:id="rId2"/>
+              </a:rPr>
+              <a:t>/MINTIC at </a:t>
+            </a:r>
+            <a:r>
+              <a:rPr lang="es-CO" sz="1400" dirty="0" err="1">
+                <a:hlinkClick r:id="rId2"/>
+              </a:rPr>
+              <a:t>development</a:t>
+            </a:r>
+            <a:endParaRPr lang="es-CO" sz="1400" dirty="0"/>
+          </a:p>
+          <a:p>
+            <a:pPr>
+              <a:spcAft>
+                <a:spcPts val="900"/>
+              </a:spcAft>
+            </a:pPr>
+            <a:r>
+              <a:rPr sz="1400" b="1" i="0" dirty="0">
+                <a:solidFill>
+                  <a:srgbClr val="147D88"/>
+                </a:solidFill>
+                <a:latin typeface="Calibri"/>
+              </a:rPr>
+              <a:t>✔  </a:t>
+            </a:r>
+            <a:r>
+              <a:rPr sz="1350" b="1" i="0" dirty="0">
+                <a:solidFill>
+                  <a:srgbClr val="222B33"/>
+                </a:solidFill>
+                <a:latin typeface="Calibri"/>
+              </a:rPr>
+              <a:t>Código </a:t>
+            </a:r>
+            <a:r>
+              <a:rPr sz="1350" b="1" i="0" dirty="0" err="1">
+                <a:solidFill>
+                  <a:srgbClr val="222B33"/>
+                </a:solidFill>
+                <a:latin typeface="Calibri"/>
+              </a:rPr>
+              <a:t>fuente</a:t>
+            </a:r>
+            <a:r>
+              <a:rPr sz="1350" b="1" i="0" dirty="0">
+                <a:solidFill>
+                  <a:srgbClr val="222B33"/>
+                </a:solidFill>
+                <a:latin typeface="Calibri"/>
+              </a:rPr>
+              <a:t> </a:t>
+            </a:r>
+            <a:r>
+              <a:rPr sz="1350" b="1" i="0" dirty="0" err="1">
+                <a:solidFill>
+                  <a:srgbClr val="222B33"/>
+                </a:solidFill>
+                <a:latin typeface="Calibri"/>
+              </a:rPr>
+              <a:t>organizado</a:t>
+            </a:r>
+            <a:r>
+              <a:rPr sz="1350" b="1" i="0" dirty="0">
+                <a:solidFill>
+                  <a:srgbClr val="222B33"/>
+                </a:solidFill>
+                <a:latin typeface="Calibri"/>
+              </a:rPr>
+              <a:t>:  </a:t>
+            </a:r>
+            <a:r>
+              <a:rPr sz="1350" b="0" i="0" dirty="0" err="1">
+                <a:solidFill>
+                  <a:srgbClr val="5C6B7A"/>
+                </a:solidFill>
+                <a:latin typeface="Calibri"/>
+              </a:rPr>
+              <a:t>src</a:t>
+            </a:r>
+            <a:r>
+              <a:rPr sz="1350" b="0" i="0" dirty="0">
+                <a:solidFill>
+                  <a:srgbClr val="5C6B7A"/>
+                </a:solidFill>
+                <a:latin typeface="Calibri"/>
+              </a:rPr>
+              <a:t>/ — acquire · clean · integrate · </a:t>
+            </a:r>
+            <a:r>
+              <a:rPr sz="1350" b="0" i="0" dirty="0" err="1">
+                <a:solidFill>
+                  <a:srgbClr val="5C6B7A"/>
+                </a:solidFill>
+                <a:latin typeface="Calibri"/>
+              </a:rPr>
+              <a:t>module_a</a:t>
+            </a:r>
+            <a:r>
+              <a:rPr sz="1350" b="0" i="0" dirty="0">
+                <a:solidFill>
+                  <a:srgbClr val="5C6B7A"/>
+                </a:solidFill>
+                <a:latin typeface="Calibri"/>
+              </a:rPr>
+              <a:t> · </a:t>
+            </a:r>
+            <a:r>
+              <a:rPr sz="1350" b="0" i="0" dirty="0" err="1">
+                <a:solidFill>
+                  <a:srgbClr val="5C6B7A"/>
+                </a:solidFill>
+                <a:latin typeface="Calibri"/>
+              </a:rPr>
+              <a:t>module_b</a:t>
+            </a:r>
+            <a:endParaRPr sz="1350" b="0" i="0" dirty="0">
+              <a:solidFill>
+                <a:srgbClr val="5C6B7A"/>
+              </a:solidFill>
+              <a:latin typeface="Calibri"/>
+            </a:endParaRPr>
+          </a:p>
           <a:p>
             <a:pPr algn="l">
               <a:spcAft>
@@ -14485,7 +15031,7 @@
               </a:spcAft>
             </a:pPr>
             <a:r>
-              <a:rPr sz="1400" b="1" i="0">
+              <a:rPr sz="1400" b="1" i="0" dirty="0">
                 <a:solidFill>
                   <a:srgbClr val="147D88"/>
                 </a:solidFill>
@@ -14494,22 +15040,58 @@
               <a:t>✔  </a:t>
             </a:r>
             <a:r>
-              <a:rPr sz="1350" b="1" i="0">
+              <a:rPr sz="1350" b="1" i="0" dirty="0">
                 <a:solidFill>
                   <a:srgbClr val="222B33"/>
                 </a:solidFill>
                 <a:latin typeface="Calibri"/>
               </a:rPr>
-              <a:t>Repositorio:  </a:t>
-            </a:r>
-            <a:r>
-              <a:rPr sz="1350" b="0" i="0">
+              <a:t>Datos y enlaces </a:t>
+            </a:r>
+            <a:r>
+              <a:rPr sz="1350" b="1" i="0" dirty="0" err="1">
+                <a:solidFill>
+                  <a:srgbClr val="222B33"/>
+                </a:solidFill>
+                <a:latin typeface="Calibri"/>
+              </a:rPr>
+              <a:t>oficiales</a:t>
+            </a:r>
+            <a:r>
+              <a:rPr sz="1350" b="1" i="0" dirty="0">
+                <a:solidFill>
+                  <a:srgbClr val="222B33"/>
+                </a:solidFill>
+                <a:latin typeface="Calibri"/>
+              </a:rPr>
+              <a:t>:  </a:t>
+            </a:r>
+            <a:r>
+              <a:rPr sz="1350" b="0" i="0" dirty="0">
                 <a:solidFill>
                   <a:srgbClr val="5C6B7A"/>
                 </a:solidFill>
                 <a:latin typeface="Calibri"/>
               </a:rPr>
-              <a:t>[URL GitHub / GitLab del equipo]</a:t>
+              <a:t>datos.gov.co — Saber 11, Censo, </a:t>
+            </a:r>
+            <a:r>
+              <a:rPr sz="1350" b="0" i="0" dirty="0" err="1">
+                <a:solidFill>
+                  <a:srgbClr val="5C6B7A"/>
+                </a:solidFill>
+                <a:latin typeface="Calibri"/>
+              </a:rPr>
+              <a:t>Beneficiarios</a:t>
+            </a:r>
+            <a:r>
+              <a:rPr sz="1350" b="0" i="0" dirty="0">
+                <a:solidFill>
+                  <a:srgbClr val="5C6B7A"/>
+                </a:solidFill>
+                <a:latin typeface="Calibri"/>
+              </a:rPr>
+              <a:t>, DIVIPOLA</a:t>
             </a:r>
           </a:p>
           <a:p>
@@ -14519,7 +15101,7 @@
               </a:spcAft>
             </a:pPr>
             <a:r>
-              <a:rPr sz="1400" b="1" i="0">
+              <a:rPr sz="1400" b="1" i="0" dirty="0">
                 <a:solidFill>
                   <a:srgbClr val="147D88"/>
                 </a:solidFill>
@@ -14528,22 +15110,67 @@
               <a:t>✔  </a:t>
             </a:r>
             <a:r>
-              <a:rPr sz="1350" b="1" i="0">
+              <a:rPr sz="1350" b="1" i="0" dirty="0" err="1">
                 <a:solidFill>
                   <a:srgbClr val="222B33"/>
                 </a:solidFill>
                 <a:latin typeface="Calibri"/>
               </a:rPr>
-              <a:t>Código fuente organizado:  </a:t>
-            </a:r>
-            <a:r>
-              <a:rPr sz="1350" b="0" i="0">
+              <a:t>Documentación</a:t>
+            </a:r>
+            <a:r>
+              <a:rPr sz="1350" b="1" i="0" dirty="0">
+                <a:solidFill>
+                  <a:srgbClr val="222B33"/>
+                </a:solidFill>
+                <a:latin typeface="Calibri"/>
+              </a:rPr>
+              <a:t> </a:t>
+            </a:r>
+            <a:r>
+              <a:rPr sz="1350" b="1" i="0" dirty="0" err="1">
+                <a:solidFill>
+                  <a:srgbClr val="222B33"/>
+                </a:solidFill>
+                <a:latin typeface="Calibri"/>
+              </a:rPr>
+              <a:t>técnica</a:t>
+            </a:r>
+            <a:r>
+              <a:rPr sz="1350" b="1" i="0" dirty="0">
+                <a:solidFill>
+                  <a:srgbClr val="222B33"/>
+                </a:solidFill>
+                <a:latin typeface="Calibri"/>
+              </a:rPr>
+              <a:t>:  </a:t>
+            </a:r>
+            <a:r>
+              <a:rPr sz="1350" b="0" i="0" dirty="0">
                 <a:solidFill>
                   <a:srgbClr val="5C6B7A"/>
                 </a:solidFill>
                 <a:latin typeface="Calibri"/>
               </a:rPr>
-              <a:t>src/ — acquire · clean · integrate · module_a · module_b</a:t>
+              <a:t>README.md con </a:t>
+            </a:r>
+            <a:r>
+              <a:rPr sz="1350" b="0" i="0" dirty="0" err="1">
+                <a:solidFill>
+                  <a:srgbClr val="5C6B7A"/>
+                </a:solidFill>
+                <a:latin typeface="Calibri"/>
+              </a:rPr>
+              <a:t>reproducción</a:t>
+            </a:r>
+            <a:r>
+              <a:rPr sz="1350" b="0" i="0" dirty="0">
+                <a:solidFill>
+                  <a:srgbClr val="5C6B7A"/>
+                </a:solidFill>
+                <a:latin typeface="Calibri"/>
+              </a:rPr>
+              <a:t> paso a paso</a:t>
             </a:r>
           </a:p>
           <a:p>
@@ -14553,7 +15180,7 @@
               </a:spcAft>
             </a:pPr>
             <a:r>
-              <a:rPr sz="1400" b="1" i="0">
+              <a:rPr sz="1400" b="1" i="0" dirty="0">
                 <a:solidFill>
                   <a:srgbClr val="147D88"/>
                 </a:solidFill>
@@ -14562,22 +15189,94 @@
               <a:t>✔  </a:t>
             </a:r>
             <a:r>
-              <a:rPr sz="1350" b="1" i="0">
+              <a:rPr sz="1350" b="1" i="0" dirty="0">
                 <a:solidFill>
                   <a:srgbClr val="222B33"/>
                 </a:solidFill>
                 <a:latin typeface="Calibri"/>
               </a:rPr>
-              <a:t>Datos y enlaces oficiales:  </a:t>
-            </a:r>
-            <a:r>
-              <a:rPr sz="1350" b="0" i="0">
+              <a:t>Notebooks </a:t>
+            </a:r>
+            <a:r>
+              <a:rPr sz="1350" b="1" i="0" dirty="0" err="1">
+                <a:solidFill>
+                  <a:srgbClr val="222B33"/>
+                </a:solidFill>
+                <a:latin typeface="Calibri"/>
+              </a:rPr>
+              <a:t>narrativos</a:t>
+            </a:r>
+            <a:r>
+              <a:rPr sz="1350" b="1" i="0" dirty="0">
+                <a:solidFill>
+                  <a:srgbClr val="222B33"/>
+                </a:solidFill>
+                <a:latin typeface="Calibri"/>
+              </a:rPr>
+              <a:t>:  </a:t>
+            </a:r>
+            <a:r>
+              <a:rPr sz="1350" b="0" i="0" dirty="0">
                 <a:solidFill>
                   <a:srgbClr val="5C6B7A"/>
                 </a:solidFill>
                 <a:latin typeface="Calibri"/>
               </a:rPr>
-              <a:t>datos.gov.co — Saber 11, Censo, Beneficiarios, DIVIPOLA</a:t>
+              <a:t>01 </a:t>
+            </a:r>
+            <a:r>
+              <a:rPr sz="1350" b="0" i="0" dirty="0" err="1">
+                <a:solidFill>
+                  <a:srgbClr val="5C6B7A"/>
+                </a:solidFill>
+                <a:latin typeface="Calibri"/>
+              </a:rPr>
+              <a:t>limpieza</a:t>
+            </a:r>
+            <a:r>
+              <a:rPr sz="1350" b="0" i="0" dirty="0">
+                <a:solidFill>
+                  <a:srgbClr val="5C6B7A"/>
+                </a:solidFill>
+                <a:latin typeface="Calibri"/>
+              </a:rPr>
+              <a:t> · 02 </a:t>
+            </a:r>
+            <a:r>
+              <a:rPr sz="1350" b="0" i="0" dirty="0" err="1">
+                <a:solidFill>
+                  <a:srgbClr val="5C6B7A"/>
+                </a:solidFill>
+                <a:latin typeface="Calibri"/>
+              </a:rPr>
+              <a:t>módulo</a:t>
+            </a:r>
+            <a:r>
+              <a:rPr sz="1350" b="0" i="0" dirty="0">
+                <a:solidFill>
+                  <a:srgbClr val="5C6B7A"/>
+                </a:solidFill>
+                <a:latin typeface="Calibri"/>
+              </a:rPr>
+              <a:t> A · 03 </a:t>
+            </a:r>
+            <a:r>
+              <a:rPr sz="1350" b="0" i="0" dirty="0" err="1">
+                <a:solidFill>
+                  <a:srgbClr val="5C6B7A"/>
+                </a:solidFill>
+                <a:latin typeface="Calibri"/>
+              </a:rPr>
+              <a:t>módulo</a:t>
+            </a:r>
+            <a:r>
+              <a:rPr sz="1350" b="0" i="0" dirty="0">
+                <a:solidFill>
+                  <a:srgbClr val="5C6B7A"/>
+                </a:solidFill>
+                <a:latin typeface="Calibri"/>
+              </a:rPr>
+              <a:t> B</a:t>
             </a:r>
           </a:p>
           <a:p>
@@ -14587,7 +15286,7 @@
               </a:spcAft>
             </a:pPr>
             <a:r>
-              <a:rPr sz="1400" b="1" i="0">
+              <a:rPr sz="1400" b="1" i="0" dirty="0">
                 <a:solidFill>
                   <a:srgbClr val="147D88"/>
                 </a:solidFill>
@@ -14596,22 +15295,112 @@
               <a:t>✔  </a:t>
             </a:r>
             <a:r>
-              <a:rPr sz="1350" b="1" i="0">
+              <a:rPr sz="1350" b="1" i="0" dirty="0">
                 <a:solidFill>
                   <a:srgbClr val="222B33"/>
                 </a:solidFill>
                 <a:latin typeface="Calibri"/>
               </a:rPr>
-              <a:t>Documentación técnica:  </a:t>
-            </a:r>
-            <a:r>
-              <a:rPr sz="1350" b="0" i="0">
+              <a:t>Demo / </a:t>
+            </a:r>
+            <a:r>
+              <a:rPr sz="1350" b="1" i="0" dirty="0" err="1">
+                <a:solidFill>
+                  <a:srgbClr val="222B33"/>
+                </a:solidFill>
+                <a:latin typeface="Calibri"/>
+              </a:rPr>
+              <a:t>prototipo</a:t>
+            </a:r>
+            <a:r>
+              <a:rPr sz="1350" b="1" i="0" dirty="0">
+                <a:solidFill>
+                  <a:srgbClr val="222B33"/>
+                </a:solidFill>
+                <a:latin typeface="Calibri"/>
+              </a:rPr>
+              <a:t>:  </a:t>
+            </a:r>
+            <a:r>
+              <a:rPr sz="1350" b="0" i="0" dirty="0">
                 <a:solidFill>
                   <a:srgbClr val="5C6B7A"/>
                 </a:solidFill>
                 <a:latin typeface="Calibri"/>
               </a:rPr>
-              <a:t>README.md con reproducción paso a paso</a:t>
+              <a:t>app </a:t>
+            </a:r>
+            <a:r>
+              <a:rPr sz="1350" b="0" i="0" dirty="0" err="1">
+                <a:solidFill>
+                  <a:srgbClr val="5C6B7A"/>
+                </a:solidFill>
+                <a:latin typeface="Calibri"/>
+              </a:rPr>
+              <a:t>Streamlit</a:t>
+            </a:r>
+            <a:r>
+              <a:rPr sz="1350" b="0" i="0" dirty="0">
+                <a:solidFill>
+                  <a:srgbClr val="5C6B7A"/>
+                </a:solidFill>
+                <a:latin typeface="Calibri"/>
+              </a:rPr>
+              <a:t> </a:t>
+            </a:r>
+            <a:r>
+              <a:rPr sz="1350" b="0" i="0" dirty="0" err="1">
+                <a:solidFill>
+                  <a:srgbClr val="5C6B7A"/>
+                </a:solidFill>
+                <a:latin typeface="Calibri"/>
+              </a:rPr>
+              <a:t>dockerizada</a:t>
+            </a:r>
+            <a:r>
+              <a:rPr sz="1350" b="0" i="0" dirty="0">
+                <a:solidFill>
+                  <a:srgbClr val="5C6B7A"/>
+                </a:solidFill>
+                <a:latin typeface="Calibri"/>
+              </a:rPr>
+              <a:t> (:8501) — </a:t>
+            </a:r>
+            <a:r>
+              <a:rPr sz="1350" b="0" i="0" dirty="0" err="1">
+                <a:solidFill>
+                  <a:srgbClr val="5C6B7A"/>
+                </a:solidFill>
+                <a:latin typeface="Calibri"/>
+              </a:rPr>
+              <a:t>calculadora</a:t>
+            </a:r>
+            <a:r>
+              <a:rPr sz="1350" b="0" i="0" dirty="0">
+                <a:solidFill>
+                  <a:srgbClr val="5C6B7A"/>
+                </a:solidFill>
+                <a:latin typeface="Calibri"/>
+              </a:rPr>
+              <a:t> de </a:t>
+            </a:r>
+            <a:r>
+              <a:rPr sz="1350" b="0" i="0" dirty="0" err="1">
+                <a:solidFill>
+                  <a:srgbClr val="5C6B7A"/>
+                </a:solidFill>
+                <a:latin typeface="Calibri"/>
+              </a:rPr>
+              <a:t>riesgo</a:t>
+            </a:r>
+            <a:r>
+              <a:rPr sz="1350" b="0" i="0" dirty="0">
+                <a:solidFill>
+                  <a:srgbClr val="5C6B7A"/>
+                </a:solidFill>
+                <a:latin typeface="Calibri"/>
+              </a:rPr>
+              <a:t> individual</a:t>
             </a:r>
           </a:p>
           <a:p>
@@ -14621,7 +15410,7 @@
               </a:spcAft>
             </a:pPr>
             <a:r>
-              <a:rPr sz="1400" b="1" i="0">
+              <a:rPr sz="1400" b="1" i="0" dirty="0">
                 <a:solidFill>
                   <a:srgbClr val="147D88"/>
                 </a:solidFill>
@@ -14630,91 +15419,119 @@
               <a:t>✔  </a:t>
             </a:r>
             <a:r>
-              <a:rPr sz="1350" b="1" i="0">
+              <a:rPr sz="1350" b="1" i="0" dirty="0" err="1">
                 <a:solidFill>
                   <a:srgbClr val="222B33"/>
                 </a:solidFill>
                 <a:latin typeface="Calibri"/>
               </a:rPr>
-              <a:t>Notebooks narrativos:  </a:t>
-            </a:r>
-            <a:r>
-              <a:rPr sz="1350" b="0" i="0">
+              <a:t>Recursos</a:t>
+            </a:r>
+            <a:r>
+              <a:rPr sz="1350" b="1" i="0" dirty="0">
+                <a:solidFill>
+                  <a:srgbClr val="222B33"/>
+                </a:solidFill>
+                <a:latin typeface="Calibri"/>
+              </a:rPr>
+              <a:t> de </a:t>
+            </a:r>
+            <a:r>
+              <a:rPr sz="1350" b="1" i="0" dirty="0" err="1">
+                <a:solidFill>
+                  <a:srgbClr val="222B33"/>
+                </a:solidFill>
+                <a:latin typeface="Calibri"/>
+              </a:rPr>
+              <a:t>resultados</a:t>
+            </a:r>
+            <a:r>
+              <a:rPr sz="1350" b="1" i="0" dirty="0">
+                <a:solidFill>
+                  <a:srgbClr val="222B33"/>
+                </a:solidFill>
+                <a:latin typeface="Calibri"/>
+              </a:rPr>
+              <a:t>:  </a:t>
+            </a:r>
+            <a:r>
+              <a:rPr sz="1350" b="0" i="0" dirty="0">
                 <a:solidFill>
                   <a:srgbClr val="5C6B7A"/>
                 </a:solidFill>
                 <a:latin typeface="Calibri"/>
               </a:rPr>
-              <a:t>01 limpieza · 02 módulo A · 03 módulo B</a:t>
-            </a:r>
-          </a:p>
-          <a:p>
-            <a:pPr algn="l">
-              <a:spcAft>
-                <a:spcPts val="900"/>
-              </a:spcAft>
-            </a:pPr>
-            <a:r>
-              <a:rPr sz="1400" b="1" i="0">
-                <a:solidFill>
-                  <a:srgbClr val="147D88"/>
-                </a:solidFill>
-                <a:latin typeface="Calibri"/>
-              </a:rPr>
-              <a:t>✔  </a:t>
-            </a:r>
-            <a:r>
-              <a:rPr sz="1350" b="1" i="0">
-                <a:solidFill>
-                  <a:srgbClr val="222B33"/>
-                </a:solidFill>
-                <a:latin typeface="Calibri"/>
-              </a:rPr>
-              <a:t>Demo / prototipo:  </a:t>
-            </a:r>
-            <a:r>
-              <a:rPr sz="1350" b="0" i="0">
+              <a:t>outputs/ — </a:t>
+            </a:r>
+            <a:r>
+              <a:rPr sz="1350" b="0" i="0" dirty="0" err="1">
                 <a:solidFill>
                   <a:srgbClr val="5C6B7A"/>
                 </a:solidFill>
                 <a:latin typeface="Calibri"/>
               </a:rPr>
-              <a:t>app Streamlit dockerizada (:8501) — calculadora de riesgo individual</a:t>
-            </a:r>
-          </a:p>
-          <a:p>
-            <a:pPr algn="l">
-              <a:spcAft>
-                <a:spcPts val="900"/>
-              </a:spcAft>
-            </a:pPr>
-            <a:r>
-              <a:rPr sz="1400" b="1" i="0">
-                <a:solidFill>
-                  <a:srgbClr val="147D88"/>
-                </a:solidFill>
-                <a:latin typeface="Calibri"/>
-              </a:rPr>
-              <a:t>✔  </a:t>
-            </a:r>
-            <a:r>
-              <a:rPr sz="1350" b="1" i="0">
-                <a:solidFill>
-                  <a:srgbClr val="222B33"/>
-                </a:solidFill>
-                <a:latin typeface="Calibri"/>
-              </a:rPr>
-              <a:t>Recursos de resultados:  </a:t>
-            </a:r>
-            <a:r>
-              <a:rPr sz="1350" b="0" i="0">
+              <a:t>modelo</a:t>
+            </a:r>
+            <a:r>
+              <a:rPr sz="1350" b="0" i="0" dirty="0">
                 <a:solidFill>
                   <a:srgbClr val="5C6B7A"/>
                 </a:solidFill>
                 <a:latin typeface="Calibri"/>
               </a:rPr>
-              <a:t>outputs/ — modelo, métricas, ranking, mapa, figuras</a:t>
-            </a:r>
+              <a:t>, </a:t>
+            </a:r>
+            <a:r>
+              <a:rPr sz="1350" b="0" i="0" dirty="0" err="1">
+                <a:solidFill>
+                  <a:srgbClr val="5C6B7A"/>
+                </a:solidFill>
+                <a:latin typeface="Calibri"/>
+              </a:rPr>
+              <a:t>métricas</a:t>
+            </a:r>
+            <a:r>
+              <a:rPr sz="1350" b="0" i="0" dirty="0">
+                <a:solidFill>
+                  <a:srgbClr val="5C6B7A"/>
+                </a:solidFill>
+                <a:latin typeface="Calibri"/>
+              </a:rPr>
+              <a:t>, ranking, </a:t>
+            </a:r>
+            <a:r>
+              <a:rPr sz="1350" b="0" i="0" dirty="0" err="1">
+                <a:solidFill>
+                  <a:srgbClr val="5C6B7A"/>
+                </a:solidFill>
+                <a:latin typeface="Calibri"/>
+              </a:rPr>
+              <a:t>mapa</a:t>
+            </a:r>
+            <a:r>
+              <a:rPr sz="1350" b="0" i="0" dirty="0">
+                <a:solidFill>
+                  <a:srgbClr val="5C6B7A"/>
+                </a:solidFill>
+                <a:latin typeface="Calibri"/>
+              </a:rPr>
+              <a:t>, </a:t>
+            </a:r>
+            <a:r>
+              <a:rPr sz="1350" b="0" i="0" dirty="0" err="1">
+                <a:solidFill>
+                  <a:srgbClr val="5C6B7A"/>
+                </a:solidFill>
+                <a:latin typeface="Calibri"/>
+              </a:rPr>
+              <a:t>figuras</a:t>
+            </a:r>
+            <a:endParaRPr sz="1350" b="0" i="0" dirty="0">
+              <a:solidFill>
+                <a:srgbClr val="5C6B7A"/>
+              </a:solidFill>
+              <a:latin typeface="Calibri"/>
+            </a:endParaRPr>
           </a:p>
         </p:txBody>
       </p:sp>
@@ -14761,6 +15578,7 @@
           <a:lstStyle/>
           <a:p>
             <a:pPr algn="ctr"/>
+            <a:endParaRPr/>
           </a:p>
         </p:txBody>
       </p:sp>
@@ -14781,7 +15599,7 @@
           <a:noFill/>
         </p:spPr>
         <p:txBody>
-          <a:bodyPr wrap="square" anchor="t" lIns="0" rIns="0" tIns="0" bIns="0">
+          <a:bodyPr wrap="square" lIns="0" tIns="0" rIns="0" bIns="0" anchor="t">
             <a:spAutoFit/>
           </a:bodyPr>
           <a:lstStyle/>
@@ -14816,7 +15634,7 @@
           <a:noFill/>
         </p:spPr>
         <p:txBody>
-          <a:bodyPr wrap="square" anchor="t" lIns="0" rIns="0" tIns="0" bIns="0">
+          <a:bodyPr wrap="square" lIns="0" tIns="0" rIns="0" bIns="0" anchor="t">
             <a:spAutoFit/>
           </a:bodyPr>
           <a:lstStyle/>
@@ -14923,7 +15741,7 @@
           <a:noFill/>
         </p:spPr>
         <p:txBody>
-          <a:bodyPr wrap="square" anchor="t" lIns="0" rIns="0" tIns="0" bIns="0">
+          <a:bodyPr wrap="square" lIns="0" tIns="0" rIns="0" bIns="0" anchor="t">
             <a:spAutoFit/>
           </a:bodyPr>
           <a:lstStyle/>
@@ -14954,10 +15772,10 @@
   <a:themeElements>
     <a:clrScheme name="Office">
       <a:dk1>
-        <a:sysClr val="windowText" lastClr="000000"/>
+        <a:sysClr val="windowText" lastClr="FFFFFF"/>
       </a:dk1>
       <a:lt1>
-        <a:sysClr val="window" lastClr="FFFFFF"/>
+        <a:sysClr val="window" lastClr="202020"/>
       </a:lt1>
       <a:dk2>
         <a:srgbClr val="1F497D"/>

</xml_diff>